<commit_message>
prezentacja i końcowe wytrenowanie
</commit_message>
<xml_diff>
--- a/Kwantyzacja.pptx
+++ b/Kwantyzacja.pptx
@@ -11,6 +11,23 @@
     <p:sldId id="259" r:id="rId5"/>
     <p:sldId id="260" r:id="rId6"/>
     <p:sldId id="261" r:id="rId7"/>
+    <p:sldId id="263" r:id="rId8"/>
+    <p:sldId id="262" r:id="rId9"/>
+    <p:sldId id="264" r:id="rId10"/>
+    <p:sldId id="265" r:id="rId11"/>
+    <p:sldId id="266" r:id="rId12"/>
+    <p:sldId id="272" r:id="rId13"/>
+    <p:sldId id="267" r:id="rId14"/>
+    <p:sldId id="268" r:id="rId15"/>
+    <p:sldId id="269" r:id="rId16"/>
+    <p:sldId id="270" r:id="rId17"/>
+    <p:sldId id="271" r:id="rId18"/>
+    <p:sldId id="273" r:id="rId19"/>
+    <p:sldId id="275" r:id="rId20"/>
+    <p:sldId id="274" r:id="rId21"/>
+    <p:sldId id="276" r:id="rId22"/>
+    <p:sldId id="277" r:id="rId23"/>
+    <p:sldId id="278" r:id="rId24"/>
   </p:sldIdLst>
   <p:sldSz cx="12192000" cy="6858000"/>
   <p:notesSz cx="6858000" cy="9144000"/>
@@ -109,6 +126,11 @@
       </a:defRPr>
     </a:lvl9pPr>
   </p:defaultTextStyle>
+  <p:extLst>
+    <p:ext uri="{EFAFB233-063F-42B5-8137-9DF3F51BA10A}">
+      <p15:sldGuideLst xmlns:p15="http://schemas.microsoft.com/office/powerpoint/2012/main"/>
+    </p:ext>
+  </p:extLst>
 </p:presentation>
 </file>
 
@@ -282,7 +304,7 @@
           <a:p>
             <a:fld id="{85100500-ABE9-4D3D-826D-1F8A5C447688}" type="datetimeFigureOut">
               <a:rPr lang="pl-PL" smtClean="0"/>
-              <a:t>05.06.2026</a:t>
+              <a:t>08.06.2026</a:t>
             </a:fld>
             <a:endParaRPr lang="pl-PL"/>
           </a:p>
@@ -549,7 +571,7 @@
           <a:p>
             <a:fld id="{85100500-ABE9-4D3D-826D-1F8A5C447688}" type="datetimeFigureOut">
               <a:rPr lang="pl-PL" smtClean="0"/>
-              <a:t>05.06.2026</a:t>
+              <a:t>08.06.2026</a:t>
             </a:fld>
             <a:endParaRPr lang="pl-PL"/>
           </a:p>
@@ -780,7 +802,7 @@
           <a:p>
             <a:fld id="{85100500-ABE9-4D3D-826D-1F8A5C447688}" type="datetimeFigureOut">
               <a:rPr lang="pl-PL" smtClean="0"/>
-              <a:t>05.06.2026</a:t>
+              <a:t>08.06.2026</a:t>
             </a:fld>
             <a:endParaRPr lang="pl-PL"/>
           </a:p>
@@ -1090,7 +1112,7 @@
           <a:p>
             <a:fld id="{85100500-ABE9-4D3D-826D-1F8A5C447688}" type="datetimeFigureOut">
               <a:rPr lang="pl-PL" smtClean="0"/>
-              <a:t>05.06.2026</a:t>
+              <a:t>08.06.2026</a:t>
             </a:fld>
             <a:endParaRPr lang="pl-PL"/>
           </a:p>
@@ -1563,7 +1585,7 @@
           <a:p>
             <a:fld id="{85100500-ABE9-4D3D-826D-1F8A5C447688}" type="datetimeFigureOut">
               <a:rPr lang="pl-PL" smtClean="0"/>
-              <a:t>05.06.2026</a:t>
+              <a:t>08.06.2026</a:t>
             </a:fld>
             <a:endParaRPr lang="pl-PL"/>
           </a:p>
@@ -2110,7 +2132,7 @@
           <a:p>
             <a:fld id="{85100500-ABE9-4D3D-826D-1F8A5C447688}" type="datetimeFigureOut">
               <a:rPr lang="pl-PL" smtClean="0"/>
-              <a:t>05.06.2026</a:t>
+              <a:t>08.06.2026</a:t>
             </a:fld>
             <a:endParaRPr lang="pl-PL"/>
           </a:p>
@@ -2884,7 +2906,7 @@
           <a:p>
             <a:fld id="{85100500-ABE9-4D3D-826D-1F8A5C447688}" type="datetimeFigureOut">
               <a:rPr lang="pl-PL" smtClean="0"/>
-              <a:t>05.06.2026</a:t>
+              <a:t>08.06.2026</a:t>
             </a:fld>
             <a:endParaRPr lang="pl-PL"/>
           </a:p>
@@ -3059,7 +3081,7 @@
           <a:p>
             <a:fld id="{85100500-ABE9-4D3D-826D-1F8A5C447688}" type="datetimeFigureOut">
               <a:rPr lang="pl-PL" smtClean="0"/>
-              <a:t>05.06.2026</a:t>
+              <a:t>08.06.2026</a:t>
             </a:fld>
             <a:endParaRPr lang="pl-PL"/>
           </a:p>
@@ -3282,7 +3304,7 @@
           <a:p>
             <a:fld id="{85100500-ABE9-4D3D-826D-1F8A5C447688}" type="datetimeFigureOut">
               <a:rPr lang="pl-PL" smtClean="0"/>
-              <a:t>05.06.2026</a:t>
+              <a:t>08.06.2026</a:t>
             </a:fld>
             <a:endParaRPr lang="pl-PL"/>
           </a:p>
@@ -3462,7 +3484,7 @@
           <a:p>
             <a:fld id="{85100500-ABE9-4D3D-826D-1F8A5C447688}" type="datetimeFigureOut">
               <a:rPr lang="pl-PL" smtClean="0"/>
-              <a:t>05.06.2026</a:t>
+              <a:t>08.06.2026</a:t>
             </a:fld>
             <a:endParaRPr lang="pl-PL"/>
           </a:p>
@@ -3751,7 +3773,7 @@
           <a:p>
             <a:fld id="{85100500-ABE9-4D3D-826D-1F8A5C447688}" type="datetimeFigureOut">
               <a:rPr lang="pl-PL" smtClean="0"/>
-              <a:t>05.06.2026</a:t>
+              <a:t>08.06.2026</a:t>
             </a:fld>
             <a:endParaRPr lang="pl-PL"/>
           </a:p>
@@ -3993,7 +4015,7 @@
           <a:p>
             <a:fld id="{85100500-ABE9-4D3D-826D-1F8A5C447688}" type="datetimeFigureOut">
               <a:rPr lang="pl-PL" smtClean="0"/>
-              <a:t>05.06.2026</a:t>
+              <a:t>08.06.2026</a:t>
             </a:fld>
             <a:endParaRPr lang="pl-PL"/>
           </a:p>
@@ -4372,7 +4394,7 @@
           <a:p>
             <a:fld id="{85100500-ABE9-4D3D-826D-1F8A5C447688}" type="datetimeFigureOut">
               <a:rPr lang="pl-PL" smtClean="0"/>
-              <a:t>05.06.2026</a:t>
+              <a:t>08.06.2026</a:t>
             </a:fld>
             <a:endParaRPr lang="pl-PL"/>
           </a:p>
@@ -4490,7 +4512,7 @@
           <a:p>
             <a:fld id="{85100500-ABE9-4D3D-826D-1F8A5C447688}" type="datetimeFigureOut">
               <a:rPr lang="pl-PL" smtClean="0"/>
-              <a:t>05.06.2026</a:t>
+              <a:t>08.06.2026</a:t>
             </a:fld>
             <a:endParaRPr lang="pl-PL"/>
           </a:p>
@@ -4585,7 +4607,7 @@
           <a:p>
             <a:fld id="{85100500-ABE9-4D3D-826D-1F8A5C447688}" type="datetimeFigureOut">
               <a:rPr lang="pl-PL" smtClean="0"/>
-              <a:t>05.06.2026</a:t>
+              <a:t>08.06.2026</a:t>
             </a:fld>
             <a:endParaRPr lang="pl-PL"/>
           </a:p>
@@ -4834,7 +4856,7 @@
           <a:p>
             <a:fld id="{85100500-ABE9-4D3D-826D-1F8A5C447688}" type="datetimeFigureOut">
               <a:rPr lang="pl-PL" smtClean="0"/>
-              <a:t>05.06.2026</a:t>
+              <a:t>08.06.2026</a:t>
             </a:fld>
             <a:endParaRPr lang="pl-PL"/>
           </a:p>
@@ -5091,7 +5113,7 @@
           <a:p>
             <a:fld id="{85100500-ABE9-4D3D-826D-1F8A5C447688}" type="datetimeFigureOut">
               <a:rPr lang="pl-PL" smtClean="0"/>
-              <a:t>05.06.2026</a:t>
+              <a:t>08.06.2026</a:t>
             </a:fld>
             <a:endParaRPr lang="pl-PL"/>
           </a:p>
@@ -5334,7 +5356,7 @@
           <a:p>
             <a:fld id="{85100500-ABE9-4D3D-826D-1F8A5C447688}" type="datetimeFigureOut">
               <a:rPr lang="pl-PL" smtClean="0"/>
-              <a:t>05.06.2026</a:t>
+              <a:t>08.06.2026</a:t>
             </a:fld>
             <a:endParaRPr lang="pl-PL"/>
           </a:p>
@@ -5816,6 +5838,1531 @@
 </p:sld>
 </file>
 
+<file path=ppt/slides/slide10.xml><?xml version="1.0" encoding="utf-8"?>
+<p:sld xmlns:a="http://schemas.openxmlformats.org/drawingml/2006/main" xmlns:r="http://schemas.openxmlformats.org/officeDocument/2006/relationships" xmlns:p="http://schemas.openxmlformats.org/presentationml/2006/main">
+  <p:cSld>
+    <p:spTree>
+      <p:nvGrpSpPr>
+        <p:cNvPr id="1" name="">
+          <a:extLst>
+            <a:ext uri="{FF2B5EF4-FFF2-40B4-BE49-F238E27FC236}">
+              <a16:creationId xmlns:a16="http://schemas.microsoft.com/office/drawing/2014/main" id="{80969EEE-3F38-71D4-5912-618850E5F12D}"/>
+            </a:ext>
+          </a:extLst>
+        </p:cNvPr>
+        <p:cNvGrpSpPr/>
+        <p:nvPr/>
+      </p:nvGrpSpPr>
+      <p:grpSpPr>
+        <a:xfrm>
+          <a:off x="0" y="0"/>
+          <a:ext cx="0" cy="0"/>
+          <a:chOff x="0" y="0"/>
+          <a:chExt cx="0" cy="0"/>
+        </a:xfrm>
+      </p:grpSpPr>
+      <p:sp>
+        <p:nvSpPr>
+          <p:cNvPr id="2" name="Tytuł 1">
+            <a:extLst>
+              <a:ext uri="{FF2B5EF4-FFF2-40B4-BE49-F238E27FC236}">
+                <a16:creationId xmlns:a16="http://schemas.microsoft.com/office/drawing/2014/main" id="{CD888FD3-0BF9-65A2-69FA-0063056A69DA}"/>
+              </a:ext>
+            </a:extLst>
+          </p:cNvPr>
+          <p:cNvSpPr>
+            <a:spLocks noGrp="1"/>
+          </p:cNvSpPr>
+          <p:nvPr>
+            <p:ph type="title"/>
+          </p:nvPr>
+        </p:nvSpPr>
+        <p:spPr/>
+        <p:txBody>
+          <a:bodyPr/>
+          <a:lstStyle/>
+          <a:p>
+            <a:r>
+              <a:rPr lang="pl-PL" dirty="0"/>
+              <a:t>CNN</a:t>
+            </a:r>
+          </a:p>
+        </p:txBody>
+      </p:sp>
+      <p:sp>
+        <p:nvSpPr>
+          <p:cNvPr id="3" name="Symbol zastępczy zawartości 2">
+            <a:extLst>
+              <a:ext uri="{FF2B5EF4-FFF2-40B4-BE49-F238E27FC236}">
+                <a16:creationId xmlns:a16="http://schemas.microsoft.com/office/drawing/2014/main" id="{45755B0F-D1FC-D49E-CE08-835799CF55C5}"/>
+              </a:ext>
+            </a:extLst>
+          </p:cNvPr>
+          <p:cNvSpPr>
+            <a:spLocks noGrp="1"/>
+          </p:cNvSpPr>
+          <p:nvPr>
+            <p:ph idx="1"/>
+          </p:nvPr>
+        </p:nvSpPr>
+        <p:spPr/>
+        <p:txBody>
+          <a:bodyPr/>
+          <a:lstStyle/>
+          <a:p>
+            <a:endParaRPr lang="pl-PL" dirty="0"/>
+          </a:p>
+          <a:p>
+            <a:pPr marL="457200" lvl="1" indent="0">
+              <a:buNone/>
+            </a:pPr>
+            <a:endParaRPr lang="pl-PL" dirty="0"/>
+          </a:p>
+        </p:txBody>
+      </p:sp>
+      <p:pic>
+        <p:nvPicPr>
+          <p:cNvPr id="5" name="Obraz 4">
+            <a:extLst>
+              <a:ext uri="{FF2B5EF4-FFF2-40B4-BE49-F238E27FC236}">
+                <a16:creationId xmlns:a16="http://schemas.microsoft.com/office/drawing/2014/main" id="{BF5B1086-FE94-F9FB-D3C3-592F1D90CB46}"/>
+              </a:ext>
+            </a:extLst>
+          </p:cNvPr>
+          <p:cNvPicPr>
+            <a:picLocks noChangeAspect="1"/>
+          </p:cNvPicPr>
+          <p:nvPr/>
+        </p:nvPicPr>
+        <p:blipFill>
+          <a:blip r:embed="rId2"/>
+          <a:stretch>
+            <a:fillRect/>
+          </a:stretch>
+        </p:blipFill>
+        <p:spPr>
+          <a:xfrm>
+            <a:off x="2514600" y="2194560"/>
+            <a:ext cx="7162800" cy="3816610"/>
+          </a:xfrm>
+          <a:prstGeom prst="rect">
+            <a:avLst/>
+          </a:prstGeom>
+        </p:spPr>
+      </p:pic>
+    </p:spTree>
+    <p:extLst>
+      <p:ext uri="{BB962C8B-B14F-4D97-AF65-F5344CB8AC3E}">
+        <p14:creationId xmlns:p14="http://schemas.microsoft.com/office/powerpoint/2010/main" val="2150166248"/>
+      </p:ext>
+    </p:extLst>
+  </p:cSld>
+  <p:clrMapOvr>
+    <a:masterClrMapping/>
+  </p:clrMapOvr>
+</p:sld>
+</file>
+
+<file path=ppt/slides/slide11.xml><?xml version="1.0" encoding="utf-8"?>
+<p:sld xmlns:a="http://schemas.openxmlformats.org/drawingml/2006/main" xmlns:r="http://schemas.openxmlformats.org/officeDocument/2006/relationships" xmlns:p="http://schemas.openxmlformats.org/presentationml/2006/main">
+  <p:cSld>
+    <p:spTree>
+      <p:nvGrpSpPr>
+        <p:cNvPr id="1" name="">
+          <a:extLst>
+            <a:ext uri="{FF2B5EF4-FFF2-40B4-BE49-F238E27FC236}">
+              <a16:creationId xmlns:a16="http://schemas.microsoft.com/office/drawing/2014/main" id="{36D3A195-169D-F5B2-21D2-4BCB0C806500}"/>
+            </a:ext>
+          </a:extLst>
+        </p:cNvPr>
+        <p:cNvGrpSpPr/>
+        <p:nvPr/>
+      </p:nvGrpSpPr>
+      <p:grpSpPr>
+        <a:xfrm>
+          <a:off x="0" y="0"/>
+          <a:ext cx="0" cy="0"/>
+          <a:chOff x="0" y="0"/>
+          <a:chExt cx="0" cy="0"/>
+        </a:xfrm>
+      </p:grpSpPr>
+      <p:sp>
+        <p:nvSpPr>
+          <p:cNvPr id="2" name="Tytuł 1">
+            <a:extLst>
+              <a:ext uri="{FF2B5EF4-FFF2-40B4-BE49-F238E27FC236}">
+                <a16:creationId xmlns:a16="http://schemas.microsoft.com/office/drawing/2014/main" id="{989E7D97-FD7A-5CD5-C590-1088F8E53D9A}"/>
+              </a:ext>
+            </a:extLst>
+          </p:cNvPr>
+          <p:cNvSpPr>
+            <a:spLocks noGrp="1"/>
+          </p:cNvSpPr>
+          <p:nvPr>
+            <p:ph type="title"/>
+          </p:nvPr>
+        </p:nvSpPr>
+        <p:spPr/>
+        <p:txBody>
+          <a:bodyPr/>
+          <a:lstStyle/>
+          <a:p>
+            <a:r>
+              <a:rPr lang="pl-PL" dirty="0" err="1"/>
+              <a:t>Triganometric</a:t>
+            </a:r>
+            <a:r>
+              <a:rPr lang="pl-PL" dirty="0"/>
+              <a:t> </a:t>
+            </a:r>
+            <a:r>
+              <a:rPr lang="pl-PL" dirty="0" err="1"/>
+              <a:t>regressor</a:t>
+            </a:r>
+            <a:endParaRPr lang="pl-PL" dirty="0"/>
+          </a:p>
+        </p:txBody>
+      </p:sp>
+      <p:sp>
+        <p:nvSpPr>
+          <p:cNvPr id="3" name="Symbol zastępczy zawartości 2">
+            <a:extLst>
+              <a:ext uri="{FF2B5EF4-FFF2-40B4-BE49-F238E27FC236}">
+                <a16:creationId xmlns:a16="http://schemas.microsoft.com/office/drawing/2014/main" id="{65FF4DD0-2CE1-F85A-94BF-A56B4C532DA0}"/>
+              </a:ext>
+            </a:extLst>
+          </p:cNvPr>
+          <p:cNvSpPr>
+            <a:spLocks noGrp="1"/>
+          </p:cNvSpPr>
+          <p:nvPr>
+            <p:ph idx="1"/>
+          </p:nvPr>
+        </p:nvSpPr>
+        <p:spPr/>
+        <p:txBody>
+          <a:bodyPr/>
+          <a:lstStyle/>
+          <a:p>
+            <a:endParaRPr lang="pl-PL" dirty="0"/>
+          </a:p>
+          <a:p>
+            <a:pPr marL="457200" lvl="1" indent="0">
+              <a:buNone/>
+            </a:pPr>
+            <a:endParaRPr lang="pl-PL" dirty="0"/>
+          </a:p>
+        </p:txBody>
+      </p:sp>
+      <p:pic>
+        <p:nvPicPr>
+          <p:cNvPr id="5" name="Obraz 4">
+            <a:extLst>
+              <a:ext uri="{FF2B5EF4-FFF2-40B4-BE49-F238E27FC236}">
+                <a16:creationId xmlns:a16="http://schemas.microsoft.com/office/drawing/2014/main" id="{B95E4121-1A4D-A128-B6DF-33C5D489A0A2}"/>
+              </a:ext>
+            </a:extLst>
+          </p:cNvPr>
+          <p:cNvPicPr>
+            <a:picLocks noChangeAspect="1"/>
+          </p:cNvPicPr>
+          <p:nvPr/>
+        </p:nvPicPr>
+        <p:blipFill>
+          <a:blip r:embed="rId2"/>
+          <a:stretch>
+            <a:fillRect/>
+          </a:stretch>
+        </p:blipFill>
+        <p:spPr>
+          <a:xfrm>
+            <a:off x="1989137" y="2003411"/>
+            <a:ext cx="8213725" cy="4090216"/>
+          </a:xfrm>
+          <a:prstGeom prst="rect">
+            <a:avLst/>
+          </a:prstGeom>
+        </p:spPr>
+      </p:pic>
+    </p:spTree>
+    <p:extLst>
+      <p:ext uri="{BB962C8B-B14F-4D97-AF65-F5344CB8AC3E}">
+        <p14:creationId xmlns:p14="http://schemas.microsoft.com/office/powerpoint/2010/main" val="3127050321"/>
+      </p:ext>
+    </p:extLst>
+  </p:cSld>
+  <p:clrMapOvr>
+    <a:masterClrMapping/>
+  </p:clrMapOvr>
+</p:sld>
+</file>
+
+<file path=ppt/slides/slide12.xml><?xml version="1.0" encoding="utf-8"?>
+<p:sld xmlns:a="http://schemas.openxmlformats.org/drawingml/2006/main" xmlns:r="http://schemas.openxmlformats.org/officeDocument/2006/relationships" xmlns:p="http://schemas.openxmlformats.org/presentationml/2006/main">
+  <p:cSld>
+    <p:spTree>
+      <p:nvGrpSpPr>
+        <p:cNvPr id="1" name="">
+          <a:extLst>
+            <a:ext uri="{FF2B5EF4-FFF2-40B4-BE49-F238E27FC236}">
+              <a16:creationId xmlns:a16="http://schemas.microsoft.com/office/drawing/2014/main" id="{667ADE54-2DA3-C611-2786-E083C47DE433}"/>
+            </a:ext>
+          </a:extLst>
+        </p:cNvPr>
+        <p:cNvGrpSpPr/>
+        <p:nvPr/>
+      </p:nvGrpSpPr>
+      <p:grpSpPr>
+        <a:xfrm>
+          <a:off x="0" y="0"/>
+          <a:ext cx="0" cy="0"/>
+          <a:chOff x="0" y="0"/>
+          <a:chExt cx="0" cy="0"/>
+        </a:xfrm>
+      </p:grpSpPr>
+      <p:sp>
+        <p:nvSpPr>
+          <p:cNvPr id="2" name="Tytuł 1">
+            <a:extLst>
+              <a:ext uri="{FF2B5EF4-FFF2-40B4-BE49-F238E27FC236}">
+                <a16:creationId xmlns:a16="http://schemas.microsoft.com/office/drawing/2014/main" id="{D2CB958D-DEEC-A8D8-8B1A-2346881E9CF4}"/>
+              </a:ext>
+            </a:extLst>
+          </p:cNvPr>
+          <p:cNvSpPr>
+            <a:spLocks noGrp="1"/>
+          </p:cNvSpPr>
+          <p:nvPr>
+            <p:ph type="title"/>
+          </p:nvPr>
+        </p:nvSpPr>
+        <p:spPr/>
+        <p:txBody>
+          <a:bodyPr/>
+          <a:lstStyle/>
+          <a:p>
+            <a:r>
+              <a:rPr lang="pl-PL" dirty="0"/>
+              <a:t>Rozmiary sieci</a:t>
+            </a:r>
+          </a:p>
+        </p:txBody>
+      </p:sp>
+      <p:sp>
+        <p:nvSpPr>
+          <p:cNvPr id="3" name="Symbol zastępczy zawartości 2">
+            <a:extLst>
+              <a:ext uri="{FF2B5EF4-FFF2-40B4-BE49-F238E27FC236}">
+                <a16:creationId xmlns:a16="http://schemas.microsoft.com/office/drawing/2014/main" id="{4C58DF56-A86F-5F9D-21A1-53A93E0C6332}"/>
+              </a:ext>
+            </a:extLst>
+          </p:cNvPr>
+          <p:cNvSpPr>
+            <a:spLocks noGrp="1"/>
+          </p:cNvSpPr>
+          <p:nvPr>
+            <p:ph idx="1"/>
+          </p:nvPr>
+        </p:nvSpPr>
+        <p:spPr/>
+        <p:txBody>
+          <a:bodyPr/>
+          <a:lstStyle/>
+          <a:p>
+            <a:endParaRPr lang="pl-PL" dirty="0"/>
+          </a:p>
+          <a:p>
+            <a:pPr lvl="1"/>
+            <a:r>
+              <a:rPr lang="pl-PL" dirty="0"/>
+              <a:t>W przypadku dużych modeli (CNN, duży MLP, </a:t>
+            </a:r>
+            <a:r>
+              <a:rPr lang="pl-PL" dirty="0" err="1"/>
+              <a:t>Regressor</a:t>
+            </a:r>
+            <a:r>
+              <a:rPr lang="pl-PL" dirty="0"/>
+              <a:t>) – zachowanie jest zgodne z przewidywanym; N-krotna kompresja rozmiaru wagi daje N-krotne zmniejszenie rozmiaru zajmowanego przez model.</a:t>
+            </a:r>
+          </a:p>
+          <a:p>
+            <a:pPr lvl="1"/>
+            <a:r>
+              <a:rPr lang="pl-PL" dirty="0"/>
+              <a:t>W ten sposób możemy uzyskać 2-krotnie lub nawet 4-krotnie mniejszy rozmiar modelu.</a:t>
+            </a:r>
+          </a:p>
+          <a:p>
+            <a:pPr lvl="1"/>
+            <a:r>
+              <a:rPr lang="pl-PL" dirty="0"/>
+              <a:t>Dla małych modeli kwantyzacja nie daje oczekiwanych rezultatów, ze względu na:</a:t>
+            </a:r>
+          </a:p>
+          <a:p>
+            <a:pPr lvl="2"/>
+            <a:r>
+              <a:rPr lang="pl-PL" dirty="0"/>
+              <a:t>Narzut na metadane</a:t>
+            </a:r>
+          </a:p>
+          <a:p>
+            <a:pPr lvl="2"/>
+            <a:r>
+              <a:rPr lang="pl-PL" dirty="0"/>
+              <a:t>Narzut na dynamiczną kwantyzację</a:t>
+            </a:r>
+          </a:p>
+          <a:p>
+            <a:pPr lvl="2"/>
+            <a:r>
+              <a:rPr lang="pl-PL" dirty="0"/>
+              <a:t>Memory </a:t>
+            </a:r>
+            <a:r>
+              <a:rPr lang="pl-PL" dirty="0" err="1"/>
+              <a:t>Alignment</a:t>
+            </a:r>
+            <a:endParaRPr lang="pl-PL" dirty="0"/>
+          </a:p>
+        </p:txBody>
+      </p:sp>
+    </p:spTree>
+    <p:extLst>
+      <p:ext uri="{BB962C8B-B14F-4D97-AF65-F5344CB8AC3E}">
+        <p14:creationId xmlns:p14="http://schemas.microsoft.com/office/powerpoint/2010/main" val="2663305882"/>
+      </p:ext>
+    </p:extLst>
+  </p:cSld>
+  <p:clrMapOvr>
+    <a:masterClrMapping/>
+  </p:clrMapOvr>
+</p:sld>
+</file>
+
+<file path=ppt/slides/slide13.xml><?xml version="1.0" encoding="utf-8"?>
+<p:sld xmlns:a="http://schemas.openxmlformats.org/drawingml/2006/main" xmlns:r="http://schemas.openxmlformats.org/officeDocument/2006/relationships" xmlns:p="http://schemas.openxmlformats.org/presentationml/2006/main">
+  <p:cSld>
+    <p:spTree>
+      <p:nvGrpSpPr>
+        <p:cNvPr id="1" name="">
+          <a:extLst>
+            <a:ext uri="{FF2B5EF4-FFF2-40B4-BE49-F238E27FC236}">
+              <a16:creationId xmlns:a16="http://schemas.microsoft.com/office/drawing/2014/main" id="{591FB1B2-9088-1C81-1CF6-F5DA8DC94E63}"/>
+            </a:ext>
+          </a:extLst>
+        </p:cNvPr>
+        <p:cNvGrpSpPr/>
+        <p:nvPr/>
+      </p:nvGrpSpPr>
+      <p:grpSpPr>
+        <a:xfrm>
+          <a:off x="0" y="0"/>
+          <a:ext cx="0" cy="0"/>
+          <a:chOff x="0" y="0"/>
+          <a:chExt cx="0" cy="0"/>
+        </a:xfrm>
+      </p:grpSpPr>
+      <p:sp>
+        <p:nvSpPr>
+          <p:cNvPr id="2" name="Tytuł 1">
+            <a:extLst>
+              <a:ext uri="{FF2B5EF4-FFF2-40B4-BE49-F238E27FC236}">
+                <a16:creationId xmlns:a16="http://schemas.microsoft.com/office/drawing/2014/main" id="{547DDE7A-1F4B-39EA-A951-EBC3BCCEE561}"/>
+              </a:ext>
+            </a:extLst>
+          </p:cNvPr>
+          <p:cNvSpPr>
+            <a:spLocks noGrp="1"/>
+          </p:cNvSpPr>
+          <p:nvPr>
+            <p:ph type="ctrTitle"/>
+          </p:nvPr>
+        </p:nvSpPr>
+        <p:spPr/>
+        <p:txBody>
+          <a:bodyPr>
+            <a:normAutofit/>
+          </a:bodyPr>
+          <a:lstStyle/>
+          <a:p>
+            <a:r>
+              <a:rPr lang="pl-PL" dirty="0"/>
+              <a:t>Jakość wyników</a:t>
+            </a:r>
+          </a:p>
+        </p:txBody>
+      </p:sp>
+      <p:sp>
+        <p:nvSpPr>
+          <p:cNvPr id="3" name="Podtytuł 2">
+            <a:extLst>
+              <a:ext uri="{FF2B5EF4-FFF2-40B4-BE49-F238E27FC236}">
+                <a16:creationId xmlns:a16="http://schemas.microsoft.com/office/drawing/2014/main" id="{4B8189C8-4751-51BC-4049-004F7433B766}"/>
+              </a:ext>
+            </a:extLst>
+          </p:cNvPr>
+          <p:cNvSpPr>
+            <a:spLocks noGrp="1"/>
+          </p:cNvSpPr>
+          <p:nvPr>
+            <p:ph type="subTitle" idx="1"/>
+          </p:nvPr>
+        </p:nvSpPr>
+        <p:spPr/>
+        <p:txBody>
+          <a:bodyPr/>
+          <a:lstStyle/>
+          <a:p>
+            <a:endParaRPr lang="pl-PL" dirty="0"/>
+          </a:p>
+        </p:txBody>
+      </p:sp>
+    </p:spTree>
+    <p:extLst>
+      <p:ext uri="{BB962C8B-B14F-4D97-AF65-F5344CB8AC3E}">
+        <p14:creationId xmlns:p14="http://schemas.microsoft.com/office/powerpoint/2010/main" val="2839629249"/>
+      </p:ext>
+    </p:extLst>
+  </p:cSld>
+  <p:clrMapOvr>
+    <a:masterClrMapping/>
+  </p:clrMapOvr>
+</p:sld>
+</file>
+
+<file path=ppt/slides/slide14.xml><?xml version="1.0" encoding="utf-8"?>
+<p:sld xmlns:a="http://schemas.openxmlformats.org/drawingml/2006/main" xmlns:r="http://schemas.openxmlformats.org/officeDocument/2006/relationships" xmlns:p="http://schemas.openxmlformats.org/presentationml/2006/main">
+  <p:cSld>
+    <p:spTree>
+      <p:nvGrpSpPr>
+        <p:cNvPr id="1" name="">
+          <a:extLst>
+            <a:ext uri="{FF2B5EF4-FFF2-40B4-BE49-F238E27FC236}">
+              <a16:creationId xmlns:a16="http://schemas.microsoft.com/office/drawing/2014/main" id="{36C78811-2E6E-2AFA-91EC-C08D4AF6FF94}"/>
+            </a:ext>
+          </a:extLst>
+        </p:cNvPr>
+        <p:cNvGrpSpPr/>
+        <p:nvPr/>
+      </p:nvGrpSpPr>
+      <p:grpSpPr>
+        <a:xfrm>
+          <a:off x="0" y="0"/>
+          <a:ext cx="0" cy="0"/>
+          <a:chOff x="0" y="0"/>
+          <a:chExt cx="0" cy="0"/>
+        </a:xfrm>
+      </p:grpSpPr>
+      <p:sp>
+        <p:nvSpPr>
+          <p:cNvPr id="2" name="Tytuł 1">
+            <a:extLst>
+              <a:ext uri="{FF2B5EF4-FFF2-40B4-BE49-F238E27FC236}">
+                <a16:creationId xmlns:a16="http://schemas.microsoft.com/office/drawing/2014/main" id="{A1C8B864-A279-67B4-9479-E787127FCA30}"/>
+              </a:ext>
+            </a:extLst>
+          </p:cNvPr>
+          <p:cNvSpPr>
+            <a:spLocks noGrp="1"/>
+          </p:cNvSpPr>
+          <p:nvPr>
+            <p:ph type="title"/>
+          </p:nvPr>
+        </p:nvSpPr>
+        <p:spPr/>
+        <p:txBody>
+          <a:bodyPr/>
+          <a:lstStyle/>
+          <a:p>
+            <a:r>
+              <a:rPr lang="pl-PL" dirty="0"/>
+              <a:t>Mały MLP</a:t>
+            </a:r>
+          </a:p>
+        </p:txBody>
+      </p:sp>
+      <p:sp>
+        <p:nvSpPr>
+          <p:cNvPr id="3" name="Symbol zastępczy zawartości 2">
+            <a:extLst>
+              <a:ext uri="{FF2B5EF4-FFF2-40B4-BE49-F238E27FC236}">
+                <a16:creationId xmlns:a16="http://schemas.microsoft.com/office/drawing/2014/main" id="{3C42BA2F-3B81-45A8-2FB8-FBEC86D204EE}"/>
+              </a:ext>
+            </a:extLst>
+          </p:cNvPr>
+          <p:cNvSpPr>
+            <a:spLocks noGrp="1"/>
+          </p:cNvSpPr>
+          <p:nvPr>
+            <p:ph idx="1"/>
+          </p:nvPr>
+        </p:nvSpPr>
+        <p:spPr/>
+        <p:txBody>
+          <a:bodyPr/>
+          <a:lstStyle/>
+          <a:p>
+            <a:endParaRPr lang="pl-PL" dirty="0"/>
+          </a:p>
+          <a:p>
+            <a:pPr marL="457200" lvl="1" indent="0">
+              <a:buNone/>
+            </a:pPr>
+            <a:endParaRPr lang="pl-PL" dirty="0"/>
+          </a:p>
+        </p:txBody>
+      </p:sp>
+      <p:pic>
+        <p:nvPicPr>
+          <p:cNvPr id="6" name="Obraz 5">
+            <a:extLst>
+              <a:ext uri="{FF2B5EF4-FFF2-40B4-BE49-F238E27FC236}">
+                <a16:creationId xmlns:a16="http://schemas.microsoft.com/office/drawing/2014/main" id="{8A3B142A-2B80-A03F-5ADD-56908293AC84}"/>
+              </a:ext>
+            </a:extLst>
+          </p:cNvPr>
+          <p:cNvPicPr>
+            <a:picLocks noChangeAspect="1"/>
+          </p:cNvPicPr>
+          <p:nvPr/>
+        </p:nvPicPr>
+        <p:blipFill>
+          <a:blip r:embed="rId2"/>
+          <a:stretch>
+            <a:fillRect/>
+          </a:stretch>
+        </p:blipFill>
+        <p:spPr>
+          <a:xfrm>
+            <a:off x="1442720" y="2258267"/>
+            <a:ext cx="3932135" cy="1948355"/>
+          </a:xfrm>
+          <a:prstGeom prst="rect">
+            <a:avLst/>
+          </a:prstGeom>
+        </p:spPr>
+      </p:pic>
+      <p:pic>
+        <p:nvPicPr>
+          <p:cNvPr id="8" name="Obraz 7">
+            <a:extLst>
+              <a:ext uri="{FF2B5EF4-FFF2-40B4-BE49-F238E27FC236}">
+                <a16:creationId xmlns:a16="http://schemas.microsoft.com/office/drawing/2014/main" id="{26A039FE-2811-935A-2522-C5C4EF069BF1}"/>
+              </a:ext>
+            </a:extLst>
+          </p:cNvPr>
+          <p:cNvPicPr>
+            <a:picLocks noChangeAspect="1"/>
+          </p:cNvPicPr>
+          <p:nvPr/>
+        </p:nvPicPr>
+        <p:blipFill>
+          <a:blip r:embed="rId3"/>
+          <a:stretch>
+            <a:fillRect/>
+          </a:stretch>
+        </p:blipFill>
+        <p:spPr>
+          <a:xfrm>
+            <a:off x="5624500" y="2257973"/>
+            <a:ext cx="3932136" cy="1940926"/>
+          </a:xfrm>
+          <a:prstGeom prst="rect">
+            <a:avLst/>
+          </a:prstGeom>
+        </p:spPr>
+      </p:pic>
+      <p:pic>
+        <p:nvPicPr>
+          <p:cNvPr id="10" name="Obraz 9">
+            <a:extLst>
+              <a:ext uri="{FF2B5EF4-FFF2-40B4-BE49-F238E27FC236}">
+                <a16:creationId xmlns:a16="http://schemas.microsoft.com/office/drawing/2014/main" id="{F217CE9B-F70C-B769-15D6-E646C0405F15}"/>
+              </a:ext>
+            </a:extLst>
+          </p:cNvPr>
+          <p:cNvPicPr>
+            <a:picLocks noChangeAspect="1"/>
+          </p:cNvPicPr>
+          <p:nvPr/>
+        </p:nvPicPr>
+        <p:blipFill>
+          <a:blip r:embed="rId4"/>
+          <a:stretch>
+            <a:fillRect/>
+          </a:stretch>
+        </p:blipFill>
+        <p:spPr>
+          <a:xfrm>
+            <a:off x="1442719" y="4342964"/>
+            <a:ext cx="3932135" cy="2005974"/>
+          </a:xfrm>
+          <a:prstGeom prst="rect">
+            <a:avLst/>
+          </a:prstGeom>
+        </p:spPr>
+      </p:pic>
+      <p:pic>
+        <p:nvPicPr>
+          <p:cNvPr id="12" name="Obraz 11">
+            <a:extLst>
+              <a:ext uri="{FF2B5EF4-FFF2-40B4-BE49-F238E27FC236}">
+                <a16:creationId xmlns:a16="http://schemas.microsoft.com/office/drawing/2014/main" id="{354E4D90-2134-FA04-0919-195DE4CBDDC9}"/>
+              </a:ext>
+            </a:extLst>
+          </p:cNvPr>
+          <p:cNvPicPr>
+            <a:picLocks noChangeAspect="1"/>
+          </p:cNvPicPr>
+          <p:nvPr/>
+        </p:nvPicPr>
+        <p:blipFill>
+          <a:blip r:embed="rId5"/>
+          <a:stretch>
+            <a:fillRect/>
+          </a:stretch>
+        </p:blipFill>
+        <p:spPr>
+          <a:xfrm>
+            <a:off x="5624500" y="4336058"/>
+            <a:ext cx="3932135" cy="2019786"/>
+          </a:xfrm>
+          <a:prstGeom prst="rect">
+            <a:avLst/>
+          </a:prstGeom>
+        </p:spPr>
+      </p:pic>
+    </p:spTree>
+    <p:extLst>
+      <p:ext uri="{BB962C8B-B14F-4D97-AF65-F5344CB8AC3E}">
+        <p14:creationId xmlns:p14="http://schemas.microsoft.com/office/powerpoint/2010/main" val="325919023"/>
+      </p:ext>
+    </p:extLst>
+  </p:cSld>
+  <p:clrMapOvr>
+    <a:masterClrMapping/>
+  </p:clrMapOvr>
+</p:sld>
+</file>
+
+<file path=ppt/slides/slide15.xml><?xml version="1.0" encoding="utf-8"?>
+<p:sld xmlns:a="http://schemas.openxmlformats.org/drawingml/2006/main" xmlns:r="http://schemas.openxmlformats.org/officeDocument/2006/relationships" xmlns:p="http://schemas.openxmlformats.org/presentationml/2006/main">
+  <p:cSld>
+    <p:spTree>
+      <p:nvGrpSpPr>
+        <p:cNvPr id="1" name="">
+          <a:extLst>
+            <a:ext uri="{FF2B5EF4-FFF2-40B4-BE49-F238E27FC236}">
+              <a16:creationId xmlns:a16="http://schemas.microsoft.com/office/drawing/2014/main" id="{950F1962-5B8C-03EC-CBFC-FF31B9D66B7C}"/>
+            </a:ext>
+          </a:extLst>
+        </p:cNvPr>
+        <p:cNvGrpSpPr/>
+        <p:nvPr/>
+      </p:nvGrpSpPr>
+      <p:grpSpPr>
+        <a:xfrm>
+          <a:off x="0" y="0"/>
+          <a:ext cx="0" cy="0"/>
+          <a:chOff x="0" y="0"/>
+          <a:chExt cx="0" cy="0"/>
+        </a:xfrm>
+      </p:grpSpPr>
+      <p:sp>
+        <p:nvSpPr>
+          <p:cNvPr id="2" name="Tytuł 1">
+            <a:extLst>
+              <a:ext uri="{FF2B5EF4-FFF2-40B4-BE49-F238E27FC236}">
+                <a16:creationId xmlns:a16="http://schemas.microsoft.com/office/drawing/2014/main" id="{A108E0A8-6E12-5EE7-C957-32DE71B26799}"/>
+              </a:ext>
+            </a:extLst>
+          </p:cNvPr>
+          <p:cNvSpPr>
+            <a:spLocks noGrp="1"/>
+          </p:cNvSpPr>
+          <p:nvPr>
+            <p:ph type="title"/>
+          </p:nvPr>
+        </p:nvSpPr>
+        <p:spPr/>
+        <p:txBody>
+          <a:bodyPr/>
+          <a:lstStyle/>
+          <a:p>
+            <a:r>
+              <a:rPr lang="pl-PL" dirty="0"/>
+              <a:t>Duży MLP</a:t>
+            </a:r>
+          </a:p>
+        </p:txBody>
+      </p:sp>
+      <p:sp>
+        <p:nvSpPr>
+          <p:cNvPr id="3" name="Symbol zastępczy zawartości 2">
+            <a:extLst>
+              <a:ext uri="{FF2B5EF4-FFF2-40B4-BE49-F238E27FC236}">
+                <a16:creationId xmlns:a16="http://schemas.microsoft.com/office/drawing/2014/main" id="{17E15BA1-9DCB-D5AD-5702-A13137DDDAE4}"/>
+              </a:ext>
+            </a:extLst>
+          </p:cNvPr>
+          <p:cNvSpPr>
+            <a:spLocks noGrp="1"/>
+          </p:cNvSpPr>
+          <p:nvPr>
+            <p:ph idx="1"/>
+          </p:nvPr>
+        </p:nvSpPr>
+        <p:spPr/>
+        <p:txBody>
+          <a:bodyPr/>
+          <a:lstStyle/>
+          <a:p>
+            <a:endParaRPr lang="pl-PL" dirty="0"/>
+          </a:p>
+          <a:p>
+            <a:pPr marL="457200" lvl="1" indent="0">
+              <a:buNone/>
+            </a:pPr>
+            <a:endParaRPr lang="pl-PL" dirty="0"/>
+          </a:p>
+        </p:txBody>
+      </p:sp>
+      <p:pic>
+        <p:nvPicPr>
+          <p:cNvPr id="5" name="Obraz 4">
+            <a:extLst>
+              <a:ext uri="{FF2B5EF4-FFF2-40B4-BE49-F238E27FC236}">
+                <a16:creationId xmlns:a16="http://schemas.microsoft.com/office/drawing/2014/main" id="{AF69DE1D-0BFA-E543-9E31-BA342642593F}"/>
+              </a:ext>
+            </a:extLst>
+          </p:cNvPr>
+          <p:cNvPicPr>
+            <a:picLocks noChangeAspect="1"/>
+          </p:cNvPicPr>
+          <p:nvPr/>
+        </p:nvPicPr>
+        <p:blipFill>
+          <a:blip r:embed="rId2"/>
+          <a:stretch>
+            <a:fillRect/>
+          </a:stretch>
+        </p:blipFill>
+        <p:spPr>
+          <a:xfrm>
+            <a:off x="1079500" y="1922842"/>
+            <a:ext cx="4062952" cy="2199578"/>
+          </a:xfrm>
+          <a:prstGeom prst="rect">
+            <a:avLst/>
+          </a:prstGeom>
+        </p:spPr>
+      </p:pic>
+      <p:pic>
+        <p:nvPicPr>
+          <p:cNvPr id="7" name="Obraz 6">
+            <a:extLst>
+              <a:ext uri="{FF2B5EF4-FFF2-40B4-BE49-F238E27FC236}">
+                <a16:creationId xmlns:a16="http://schemas.microsoft.com/office/drawing/2014/main" id="{7C41FAAC-EA78-CDB2-27A1-EF8D72DB5432}"/>
+              </a:ext>
+            </a:extLst>
+          </p:cNvPr>
+          <p:cNvPicPr>
+            <a:picLocks noChangeAspect="1"/>
+          </p:cNvPicPr>
+          <p:nvPr/>
+        </p:nvPicPr>
+        <p:blipFill>
+          <a:blip r:embed="rId3"/>
+          <a:stretch>
+            <a:fillRect/>
+          </a:stretch>
+        </p:blipFill>
+        <p:spPr>
+          <a:xfrm>
+            <a:off x="5320458" y="1922841"/>
+            <a:ext cx="4270113" cy="2199578"/>
+          </a:xfrm>
+          <a:prstGeom prst="rect">
+            <a:avLst/>
+          </a:prstGeom>
+        </p:spPr>
+      </p:pic>
+      <p:pic>
+        <p:nvPicPr>
+          <p:cNvPr id="9" name="Obraz 8">
+            <a:extLst>
+              <a:ext uri="{FF2B5EF4-FFF2-40B4-BE49-F238E27FC236}">
+                <a16:creationId xmlns:a16="http://schemas.microsoft.com/office/drawing/2014/main" id="{3752C40B-43AC-E0CF-E9E5-27316617F447}"/>
+              </a:ext>
+            </a:extLst>
+          </p:cNvPr>
+          <p:cNvPicPr>
+            <a:picLocks noChangeAspect="1"/>
+          </p:cNvPicPr>
+          <p:nvPr/>
+        </p:nvPicPr>
+        <p:blipFill>
+          <a:blip r:embed="rId4"/>
+          <a:stretch>
+            <a:fillRect/>
+          </a:stretch>
+        </p:blipFill>
+        <p:spPr>
+          <a:xfrm>
+            <a:off x="1079500" y="4276905"/>
+            <a:ext cx="4062952" cy="2107341"/>
+          </a:xfrm>
+          <a:prstGeom prst="rect">
+            <a:avLst/>
+          </a:prstGeom>
+        </p:spPr>
+      </p:pic>
+      <p:pic>
+        <p:nvPicPr>
+          <p:cNvPr id="11" name="Obraz 10">
+            <a:extLst>
+              <a:ext uri="{FF2B5EF4-FFF2-40B4-BE49-F238E27FC236}">
+                <a16:creationId xmlns:a16="http://schemas.microsoft.com/office/drawing/2014/main" id="{A58BF235-8477-8D72-D32D-8687769A3D98}"/>
+              </a:ext>
+            </a:extLst>
+          </p:cNvPr>
+          <p:cNvPicPr>
+            <a:picLocks noChangeAspect="1"/>
+          </p:cNvPicPr>
+          <p:nvPr/>
+        </p:nvPicPr>
+        <p:blipFill>
+          <a:blip r:embed="rId5"/>
+          <a:stretch>
+            <a:fillRect/>
+          </a:stretch>
+        </p:blipFill>
+        <p:spPr>
+          <a:xfrm>
+            <a:off x="5320458" y="4269452"/>
+            <a:ext cx="4210721" cy="2122248"/>
+          </a:xfrm>
+          <a:prstGeom prst="rect">
+            <a:avLst/>
+          </a:prstGeom>
+        </p:spPr>
+      </p:pic>
+    </p:spTree>
+    <p:extLst>
+      <p:ext uri="{BB962C8B-B14F-4D97-AF65-F5344CB8AC3E}">
+        <p14:creationId xmlns:p14="http://schemas.microsoft.com/office/powerpoint/2010/main" val="1001856418"/>
+      </p:ext>
+    </p:extLst>
+  </p:cSld>
+  <p:clrMapOvr>
+    <a:masterClrMapping/>
+  </p:clrMapOvr>
+</p:sld>
+</file>
+
+<file path=ppt/slides/slide16.xml><?xml version="1.0" encoding="utf-8"?>
+<p:sld xmlns:a="http://schemas.openxmlformats.org/drawingml/2006/main" xmlns:r="http://schemas.openxmlformats.org/officeDocument/2006/relationships" xmlns:p="http://schemas.openxmlformats.org/presentationml/2006/main">
+  <p:cSld>
+    <p:spTree>
+      <p:nvGrpSpPr>
+        <p:cNvPr id="1" name="">
+          <a:extLst>
+            <a:ext uri="{FF2B5EF4-FFF2-40B4-BE49-F238E27FC236}">
+              <a16:creationId xmlns:a16="http://schemas.microsoft.com/office/drawing/2014/main" id="{9A528EA7-1CB8-84B3-417B-38079397AF39}"/>
+            </a:ext>
+          </a:extLst>
+        </p:cNvPr>
+        <p:cNvGrpSpPr/>
+        <p:nvPr/>
+      </p:nvGrpSpPr>
+      <p:grpSpPr>
+        <a:xfrm>
+          <a:off x="0" y="0"/>
+          <a:ext cx="0" cy="0"/>
+          <a:chOff x="0" y="0"/>
+          <a:chExt cx="0" cy="0"/>
+        </a:xfrm>
+      </p:grpSpPr>
+      <p:sp>
+        <p:nvSpPr>
+          <p:cNvPr id="2" name="Tytuł 1">
+            <a:extLst>
+              <a:ext uri="{FF2B5EF4-FFF2-40B4-BE49-F238E27FC236}">
+                <a16:creationId xmlns:a16="http://schemas.microsoft.com/office/drawing/2014/main" id="{45B52441-3ECE-EBDA-F4E3-858FF32461D6}"/>
+              </a:ext>
+            </a:extLst>
+          </p:cNvPr>
+          <p:cNvSpPr>
+            <a:spLocks noGrp="1"/>
+          </p:cNvSpPr>
+          <p:nvPr>
+            <p:ph type="title"/>
+          </p:nvPr>
+        </p:nvSpPr>
+        <p:spPr/>
+        <p:txBody>
+          <a:bodyPr/>
+          <a:lstStyle/>
+          <a:p>
+            <a:r>
+              <a:rPr lang="pl-PL" dirty="0"/>
+              <a:t>CNN</a:t>
+            </a:r>
+          </a:p>
+        </p:txBody>
+      </p:sp>
+      <p:sp>
+        <p:nvSpPr>
+          <p:cNvPr id="3" name="Symbol zastępczy zawartości 2">
+            <a:extLst>
+              <a:ext uri="{FF2B5EF4-FFF2-40B4-BE49-F238E27FC236}">
+                <a16:creationId xmlns:a16="http://schemas.microsoft.com/office/drawing/2014/main" id="{45058F62-01CE-AC62-144A-DAF80C28F9E6}"/>
+              </a:ext>
+            </a:extLst>
+          </p:cNvPr>
+          <p:cNvSpPr>
+            <a:spLocks noGrp="1"/>
+          </p:cNvSpPr>
+          <p:nvPr>
+            <p:ph idx="1"/>
+          </p:nvPr>
+        </p:nvSpPr>
+        <p:spPr/>
+        <p:txBody>
+          <a:bodyPr/>
+          <a:lstStyle/>
+          <a:p>
+            <a:endParaRPr lang="pl-PL" dirty="0"/>
+          </a:p>
+          <a:p>
+            <a:pPr marL="457200" lvl="1" indent="0">
+              <a:buNone/>
+            </a:pPr>
+            <a:endParaRPr lang="pl-PL" dirty="0"/>
+          </a:p>
+        </p:txBody>
+      </p:sp>
+      <p:pic>
+        <p:nvPicPr>
+          <p:cNvPr id="5" name="Obraz 4">
+            <a:extLst>
+              <a:ext uri="{FF2B5EF4-FFF2-40B4-BE49-F238E27FC236}">
+                <a16:creationId xmlns:a16="http://schemas.microsoft.com/office/drawing/2014/main" id="{B392A039-5057-18B6-AAC7-A6C31F365D98}"/>
+              </a:ext>
+            </a:extLst>
+          </p:cNvPr>
+          <p:cNvPicPr>
+            <a:picLocks noChangeAspect="1"/>
+          </p:cNvPicPr>
+          <p:nvPr/>
+        </p:nvPicPr>
+        <p:blipFill>
+          <a:blip r:embed="rId2"/>
+          <a:stretch>
+            <a:fillRect/>
+          </a:stretch>
+        </p:blipFill>
+        <p:spPr>
+          <a:xfrm>
+            <a:off x="685800" y="1821454"/>
+            <a:ext cx="3980036" cy="2140946"/>
+          </a:xfrm>
+          <a:prstGeom prst="rect">
+            <a:avLst/>
+          </a:prstGeom>
+        </p:spPr>
+      </p:pic>
+      <p:pic>
+        <p:nvPicPr>
+          <p:cNvPr id="7" name="Obraz 6">
+            <a:extLst>
+              <a:ext uri="{FF2B5EF4-FFF2-40B4-BE49-F238E27FC236}">
+                <a16:creationId xmlns:a16="http://schemas.microsoft.com/office/drawing/2014/main" id="{660D890B-9909-1248-AE3F-6A2FC29DA1C9}"/>
+              </a:ext>
+            </a:extLst>
+          </p:cNvPr>
+          <p:cNvPicPr>
+            <a:picLocks noChangeAspect="1"/>
+          </p:cNvPicPr>
+          <p:nvPr/>
+        </p:nvPicPr>
+        <p:blipFill>
+          <a:blip r:embed="rId3"/>
+          <a:stretch>
+            <a:fillRect/>
+          </a:stretch>
+        </p:blipFill>
+        <p:spPr>
+          <a:xfrm>
+            <a:off x="4781974" y="1821454"/>
+            <a:ext cx="4185920" cy="2144708"/>
+          </a:xfrm>
+          <a:prstGeom prst="rect">
+            <a:avLst/>
+          </a:prstGeom>
+        </p:spPr>
+      </p:pic>
+      <p:pic>
+        <p:nvPicPr>
+          <p:cNvPr id="9" name="Obraz 8">
+            <a:extLst>
+              <a:ext uri="{FF2B5EF4-FFF2-40B4-BE49-F238E27FC236}">
+                <a16:creationId xmlns:a16="http://schemas.microsoft.com/office/drawing/2014/main" id="{02EE18C5-4043-1F07-E1CE-15B00939A9C7}"/>
+              </a:ext>
+            </a:extLst>
+          </p:cNvPr>
+          <p:cNvPicPr>
+            <a:picLocks noChangeAspect="1"/>
+          </p:cNvPicPr>
+          <p:nvPr/>
+        </p:nvPicPr>
+        <p:blipFill>
+          <a:blip r:embed="rId4"/>
+          <a:stretch>
+            <a:fillRect/>
+          </a:stretch>
+        </p:blipFill>
+        <p:spPr>
+          <a:xfrm>
+            <a:off x="685799" y="4089287"/>
+            <a:ext cx="3980037" cy="2089095"/>
+          </a:xfrm>
+          <a:prstGeom prst="rect">
+            <a:avLst/>
+          </a:prstGeom>
+        </p:spPr>
+      </p:pic>
+      <p:pic>
+        <p:nvPicPr>
+          <p:cNvPr id="11" name="Obraz 10">
+            <a:extLst>
+              <a:ext uri="{FF2B5EF4-FFF2-40B4-BE49-F238E27FC236}">
+                <a16:creationId xmlns:a16="http://schemas.microsoft.com/office/drawing/2014/main" id="{D9285069-E7BA-D7EC-6E99-AEA163866DD6}"/>
+              </a:ext>
+            </a:extLst>
+          </p:cNvPr>
+          <p:cNvPicPr>
+            <a:picLocks noChangeAspect="1"/>
+          </p:cNvPicPr>
+          <p:nvPr/>
+        </p:nvPicPr>
+        <p:blipFill>
+          <a:blip r:embed="rId5"/>
+          <a:stretch>
+            <a:fillRect/>
+          </a:stretch>
+        </p:blipFill>
+        <p:spPr>
+          <a:xfrm>
+            <a:off x="4781974" y="4073552"/>
+            <a:ext cx="4104639" cy="2117971"/>
+          </a:xfrm>
+          <a:prstGeom prst="rect">
+            <a:avLst/>
+          </a:prstGeom>
+        </p:spPr>
+      </p:pic>
+    </p:spTree>
+    <p:extLst>
+      <p:ext uri="{BB962C8B-B14F-4D97-AF65-F5344CB8AC3E}">
+        <p14:creationId xmlns:p14="http://schemas.microsoft.com/office/powerpoint/2010/main" val="1267935876"/>
+      </p:ext>
+    </p:extLst>
+  </p:cSld>
+  <p:clrMapOvr>
+    <a:masterClrMapping/>
+  </p:clrMapOvr>
+</p:sld>
+</file>
+
+<file path=ppt/slides/slide17.xml><?xml version="1.0" encoding="utf-8"?>
+<p:sld xmlns:a="http://schemas.openxmlformats.org/drawingml/2006/main" xmlns:r="http://schemas.openxmlformats.org/officeDocument/2006/relationships" xmlns:p="http://schemas.openxmlformats.org/presentationml/2006/main">
+  <p:cSld>
+    <p:spTree>
+      <p:nvGrpSpPr>
+        <p:cNvPr id="1" name="">
+          <a:extLst>
+            <a:ext uri="{FF2B5EF4-FFF2-40B4-BE49-F238E27FC236}">
+              <a16:creationId xmlns:a16="http://schemas.microsoft.com/office/drawing/2014/main" id="{B16A2AD1-E002-792F-875D-0B297F62F8A2}"/>
+            </a:ext>
+          </a:extLst>
+        </p:cNvPr>
+        <p:cNvGrpSpPr/>
+        <p:nvPr/>
+      </p:nvGrpSpPr>
+      <p:grpSpPr>
+        <a:xfrm>
+          <a:off x="0" y="0"/>
+          <a:ext cx="0" cy="0"/>
+          <a:chOff x="0" y="0"/>
+          <a:chExt cx="0" cy="0"/>
+        </a:xfrm>
+      </p:grpSpPr>
+      <p:sp>
+        <p:nvSpPr>
+          <p:cNvPr id="2" name="Tytuł 1">
+            <a:extLst>
+              <a:ext uri="{FF2B5EF4-FFF2-40B4-BE49-F238E27FC236}">
+                <a16:creationId xmlns:a16="http://schemas.microsoft.com/office/drawing/2014/main" id="{7066B733-B8AF-AB8D-4594-52D6771C75E3}"/>
+              </a:ext>
+            </a:extLst>
+          </p:cNvPr>
+          <p:cNvSpPr>
+            <a:spLocks noGrp="1"/>
+          </p:cNvSpPr>
+          <p:nvPr>
+            <p:ph type="title"/>
+          </p:nvPr>
+        </p:nvSpPr>
+        <p:spPr/>
+        <p:txBody>
+          <a:bodyPr/>
+          <a:lstStyle/>
+          <a:p>
+            <a:r>
+              <a:rPr lang="pl-PL" dirty="0" err="1"/>
+              <a:t>Triganometric</a:t>
+            </a:r>
+            <a:r>
+              <a:rPr lang="pl-PL" dirty="0"/>
+              <a:t> </a:t>
+            </a:r>
+            <a:r>
+              <a:rPr lang="pl-PL" dirty="0" err="1"/>
+              <a:t>regressor</a:t>
+            </a:r>
+            <a:endParaRPr lang="pl-PL" dirty="0"/>
+          </a:p>
+        </p:txBody>
+      </p:sp>
+      <p:sp>
+        <p:nvSpPr>
+          <p:cNvPr id="3" name="Symbol zastępczy zawartości 2">
+            <a:extLst>
+              <a:ext uri="{FF2B5EF4-FFF2-40B4-BE49-F238E27FC236}">
+                <a16:creationId xmlns:a16="http://schemas.microsoft.com/office/drawing/2014/main" id="{B4F694AA-306A-177B-9C91-3D7761C7FBAB}"/>
+              </a:ext>
+            </a:extLst>
+          </p:cNvPr>
+          <p:cNvSpPr>
+            <a:spLocks noGrp="1"/>
+          </p:cNvSpPr>
+          <p:nvPr>
+            <p:ph idx="1"/>
+          </p:nvPr>
+        </p:nvSpPr>
+        <p:spPr/>
+        <p:txBody>
+          <a:bodyPr/>
+          <a:lstStyle/>
+          <a:p>
+            <a:endParaRPr lang="pl-PL" dirty="0"/>
+          </a:p>
+          <a:p>
+            <a:pPr marL="457200" lvl="1" indent="0">
+              <a:buNone/>
+            </a:pPr>
+            <a:endParaRPr lang="pl-PL" dirty="0"/>
+          </a:p>
+        </p:txBody>
+      </p:sp>
+      <p:pic>
+        <p:nvPicPr>
+          <p:cNvPr id="5" name="Obraz 4">
+            <a:extLst>
+              <a:ext uri="{FF2B5EF4-FFF2-40B4-BE49-F238E27FC236}">
+                <a16:creationId xmlns:a16="http://schemas.microsoft.com/office/drawing/2014/main" id="{D8B7326E-799F-E9E6-E7F7-E394A3B624DC}"/>
+              </a:ext>
+            </a:extLst>
+          </p:cNvPr>
+          <p:cNvPicPr>
+            <a:picLocks noChangeAspect="1"/>
+          </p:cNvPicPr>
+          <p:nvPr/>
+        </p:nvPicPr>
+        <p:blipFill>
+          <a:blip r:embed="rId2"/>
+          <a:stretch>
+            <a:fillRect/>
+          </a:stretch>
+        </p:blipFill>
+        <p:spPr>
+          <a:xfrm>
+            <a:off x="2528389" y="2057401"/>
+            <a:ext cx="7135221" cy="3600953"/>
+          </a:xfrm>
+          <a:prstGeom prst="rect">
+            <a:avLst/>
+          </a:prstGeom>
+        </p:spPr>
+      </p:pic>
+    </p:spTree>
+    <p:extLst>
+      <p:ext uri="{BB962C8B-B14F-4D97-AF65-F5344CB8AC3E}">
+        <p14:creationId xmlns:p14="http://schemas.microsoft.com/office/powerpoint/2010/main" val="168433341"/>
+      </p:ext>
+    </p:extLst>
+  </p:cSld>
+  <p:clrMapOvr>
+    <a:masterClrMapping/>
+  </p:clrMapOvr>
+</p:sld>
+</file>
+
+<file path=ppt/slides/slide18.xml><?xml version="1.0" encoding="utf-8"?>
+<p:sld xmlns:a="http://schemas.openxmlformats.org/drawingml/2006/main" xmlns:r="http://schemas.openxmlformats.org/officeDocument/2006/relationships" xmlns:p="http://schemas.openxmlformats.org/presentationml/2006/main">
+  <p:cSld>
+    <p:spTree>
+      <p:nvGrpSpPr>
+        <p:cNvPr id="1" name="">
+          <a:extLst>
+            <a:ext uri="{FF2B5EF4-FFF2-40B4-BE49-F238E27FC236}">
+              <a16:creationId xmlns:a16="http://schemas.microsoft.com/office/drawing/2014/main" id="{4FFEE455-BF7E-DE73-7410-979E963A2D5A}"/>
+            </a:ext>
+          </a:extLst>
+        </p:cNvPr>
+        <p:cNvGrpSpPr/>
+        <p:nvPr/>
+      </p:nvGrpSpPr>
+      <p:grpSpPr>
+        <a:xfrm>
+          <a:off x="0" y="0"/>
+          <a:ext cx="0" cy="0"/>
+          <a:chOff x="0" y="0"/>
+          <a:chExt cx="0" cy="0"/>
+        </a:xfrm>
+      </p:grpSpPr>
+      <p:sp>
+        <p:nvSpPr>
+          <p:cNvPr id="2" name="Tytuł 1">
+            <a:extLst>
+              <a:ext uri="{FF2B5EF4-FFF2-40B4-BE49-F238E27FC236}">
+                <a16:creationId xmlns:a16="http://schemas.microsoft.com/office/drawing/2014/main" id="{7A7B79D8-19DB-BB25-BC37-3D5706188670}"/>
+              </a:ext>
+            </a:extLst>
+          </p:cNvPr>
+          <p:cNvSpPr>
+            <a:spLocks noGrp="1"/>
+          </p:cNvSpPr>
+          <p:nvPr>
+            <p:ph type="title"/>
+          </p:nvPr>
+        </p:nvSpPr>
+        <p:spPr/>
+        <p:txBody>
+          <a:bodyPr/>
+          <a:lstStyle/>
+          <a:p>
+            <a:r>
+              <a:rPr lang="pl-PL" dirty="0"/>
+              <a:t>Jakość wyników</a:t>
+            </a:r>
+          </a:p>
+        </p:txBody>
+      </p:sp>
+      <p:sp>
+        <p:nvSpPr>
+          <p:cNvPr id="3" name="Symbol zastępczy zawartości 2">
+            <a:extLst>
+              <a:ext uri="{FF2B5EF4-FFF2-40B4-BE49-F238E27FC236}">
+                <a16:creationId xmlns:a16="http://schemas.microsoft.com/office/drawing/2014/main" id="{B8C00367-8CEB-FD22-61C1-81E4BFE91F11}"/>
+              </a:ext>
+            </a:extLst>
+          </p:cNvPr>
+          <p:cNvSpPr>
+            <a:spLocks noGrp="1"/>
+          </p:cNvSpPr>
+          <p:nvPr>
+            <p:ph idx="1"/>
+          </p:nvPr>
+        </p:nvSpPr>
+        <p:spPr/>
+        <p:txBody>
+          <a:bodyPr/>
+          <a:lstStyle/>
+          <a:p>
+            <a:endParaRPr lang="pl-PL" dirty="0"/>
+          </a:p>
+          <a:p>
+            <a:pPr lvl="1"/>
+            <a:r>
+              <a:rPr lang="pl-PL" dirty="0"/>
+              <a:t>Wszystkie miary jakości uzyskanych wyników (dokładność, </a:t>
+            </a:r>
+            <a:r>
+              <a:rPr lang="pl-PL" dirty="0" err="1"/>
+              <a:t>prezycja</a:t>
+            </a:r>
+            <a:r>
+              <a:rPr lang="pl-PL" dirty="0"/>
+              <a:t>, czułość) w przypadku dużych modeli klasyfikujących (MLP, CNN) nie wykazują żadnego znaczącego spadku.</a:t>
+            </a:r>
+          </a:p>
+          <a:p>
+            <a:pPr lvl="1"/>
+            <a:r>
+              <a:rPr lang="pl-PL" dirty="0"/>
+              <a:t>Co ciekawe, w wielu przypadkach kwantyzacja do INT8 zapewnia lepsze wyniki niż do FLOAT16.</a:t>
+            </a:r>
+          </a:p>
+          <a:p>
+            <a:pPr lvl="2"/>
+            <a:r>
+              <a:rPr lang="pl-PL" dirty="0"/>
+              <a:t>Może być to związane z działaniem kwantyzacji jak </a:t>
+            </a:r>
+            <a:r>
+              <a:rPr lang="pl-PL" dirty="0" err="1"/>
+              <a:t>regularyzacji</a:t>
+            </a:r>
+            <a:r>
+              <a:rPr lang="pl-PL" dirty="0"/>
+              <a:t> dodającej pożądany szum</a:t>
+            </a:r>
+          </a:p>
+        </p:txBody>
+      </p:sp>
+    </p:spTree>
+    <p:extLst>
+      <p:ext uri="{BB962C8B-B14F-4D97-AF65-F5344CB8AC3E}">
+        <p14:creationId xmlns:p14="http://schemas.microsoft.com/office/powerpoint/2010/main" val="1478617891"/>
+      </p:ext>
+    </p:extLst>
+  </p:cSld>
+  <p:clrMapOvr>
+    <a:masterClrMapping/>
+  </p:clrMapOvr>
+</p:sld>
+</file>
+
+<file path=ppt/slides/slide19.xml><?xml version="1.0" encoding="utf-8"?>
+<p:sld xmlns:a="http://schemas.openxmlformats.org/drawingml/2006/main" xmlns:r="http://schemas.openxmlformats.org/officeDocument/2006/relationships" xmlns:p="http://schemas.openxmlformats.org/presentationml/2006/main">
+  <p:cSld>
+    <p:spTree>
+      <p:nvGrpSpPr>
+        <p:cNvPr id="1" name="">
+          <a:extLst>
+            <a:ext uri="{FF2B5EF4-FFF2-40B4-BE49-F238E27FC236}">
+              <a16:creationId xmlns:a16="http://schemas.microsoft.com/office/drawing/2014/main" id="{F66E1FF1-69A9-AF04-381A-FDA5E58CF1E9}"/>
+            </a:ext>
+          </a:extLst>
+        </p:cNvPr>
+        <p:cNvGrpSpPr/>
+        <p:nvPr/>
+      </p:nvGrpSpPr>
+      <p:grpSpPr>
+        <a:xfrm>
+          <a:off x="0" y="0"/>
+          <a:ext cx="0" cy="0"/>
+          <a:chOff x="0" y="0"/>
+          <a:chExt cx="0" cy="0"/>
+        </a:xfrm>
+      </p:grpSpPr>
+      <p:sp>
+        <p:nvSpPr>
+          <p:cNvPr id="2" name="Tytuł 1">
+            <a:extLst>
+              <a:ext uri="{FF2B5EF4-FFF2-40B4-BE49-F238E27FC236}">
+                <a16:creationId xmlns:a16="http://schemas.microsoft.com/office/drawing/2014/main" id="{5D4A1DF3-9F20-DA2E-76C2-2A4D25333FC3}"/>
+              </a:ext>
+            </a:extLst>
+          </p:cNvPr>
+          <p:cNvSpPr>
+            <a:spLocks noGrp="1"/>
+          </p:cNvSpPr>
+          <p:nvPr>
+            <p:ph type="title"/>
+          </p:nvPr>
+        </p:nvSpPr>
+        <p:spPr/>
+        <p:txBody>
+          <a:bodyPr/>
+          <a:lstStyle/>
+          <a:p>
+            <a:r>
+              <a:rPr lang="pl-PL" dirty="0"/>
+              <a:t>Jakość wyników</a:t>
+            </a:r>
+          </a:p>
+        </p:txBody>
+      </p:sp>
+      <p:sp>
+        <p:nvSpPr>
+          <p:cNvPr id="3" name="Symbol zastępczy zawartości 2">
+            <a:extLst>
+              <a:ext uri="{FF2B5EF4-FFF2-40B4-BE49-F238E27FC236}">
+                <a16:creationId xmlns:a16="http://schemas.microsoft.com/office/drawing/2014/main" id="{FE568A1C-164A-235A-BEEE-AB0174EB2482}"/>
+              </a:ext>
+            </a:extLst>
+          </p:cNvPr>
+          <p:cNvSpPr>
+            <a:spLocks noGrp="1"/>
+          </p:cNvSpPr>
+          <p:nvPr>
+            <p:ph idx="1"/>
+          </p:nvPr>
+        </p:nvSpPr>
+        <p:spPr/>
+        <p:txBody>
+          <a:bodyPr/>
+          <a:lstStyle/>
+          <a:p>
+            <a:endParaRPr lang="pl-PL" dirty="0"/>
+          </a:p>
+          <a:p>
+            <a:pPr lvl="1"/>
+            <a:r>
+              <a:rPr lang="pl-PL" dirty="0"/>
+              <a:t>Dla małego modelu (MLP) spadek metryk jest bardziej widoczny – kwantyzacja przynosi gorsze efekty. Widać to głównie w najbardziej miarodajnej metryce F1.</a:t>
+            </a:r>
+          </a:p>
+          <a:p>
+            <a:pPr lvl="1"/>
+            <a:r>
+              <a:rPr lang="pl-PL" dirty="0" err="1"/>
+              <a:t>Regressor</a:t>
+            </a:r>
+            <a:r>
+              <a:rPr lang="pl-PL" dirty="0"/>
+              <a:t> również ma o wiele wyższą funkcję straty po skwantowaniu modelu – nawet ok. 2-krotnie.</a:t>
+            </a:r>
+          </a:p>
+          <a:p>
+            <a:pPr lvl="2"/>
+            <a:r>
+              <a:rPr lang="pl-PL" dirty="0"/>
+              <a:t>Tutaj również występuje efekt </a:t>
+            </a:r>
+            <a:r>
+              <a:rPr lang="pl-PL" dirty="0" err="1"/>
+              <a:t>regularyzacji</a:t>
+            </a:r>
+            <a:r>
+              <a:rPr lang="pl-PL" dirty="0"/>
+              <a:t> przez kwantyzację – INT8 daje nieco lepszy wynik niż FLOAT16.</a:t>
+            </a:r>
+          </a:p>
+          <a:p>
+            <a:pPr lvl="1"/>
+            <a:endParaRPr lang="pl-PL" dirty="0"/>
+          </a:p>
+        </p:txBody>
+      </p:sp>
+    </p:spTree>
+    <p:extLst>
+      <p:ext uri="{BB962C8B-B14F-4D97-AF65-F5344CB8AC3E}">
+        <p14:creationId xmlns:p14="http://schemas.microsoft.com/office/powerpoint/2010/main" val="1315230201"/>
+      </p:ext>
+    </p:extLst>
+  </p:cSld>
+  <p:clrMapOvr>
+    <a:masterClrMapping/>
+  </p:clrMapOvr>
+</p:sld>
+</file>
+
 <file path=ppt/slides/slide2.xml><?xml version="1.0" encoding="utf-8"?>
 <p:sld xmlns:a="http://schemas.openxmlformats.org/drawingml/2006/main" xmlns:r="http://schemas.openxmlformats.org/officeDocument/2006/relationships" xmlns:p="http://schemas.openxmlformats.org/presentationml/2006/main">
   <p:cSld>
@@ -5893,6 +7440,423 @@
     <p:extLst>
       <p:ext uri="{BB962C8B-B14F-4D97-AF65-F5344CB8AC3E}">
         <p14:creationId xmlns:p14="http://schemas.microsoft.com/office/powerpoint/2010/main" val="2680811777"/>
+      </p:ext>
+    </p:extLst>
+  </p:cSld>
+  <p:clrMapOvr>
+    <a:masterClrMapping/>
+  </p:clrMapOvr>
+</p:sld>
+</file>
+
+<file path=ppt/slides/slide20.xml><?xml version="1.0" encoding="utf-8"?>
+<p:sld xmlns:a="http://schemas.openxmlformats.org/drawingml/2006/main" xmlns:r="http://schemas.openxmlformats.org/officeDocument/2006/relationships" xmlns:p="http://schemas.openxmlformats.org/presentationml/2006/main">
+  <p:cSld>
+    <p:spTree>
+      <p:nvGrpSpPr>
+        <p:cNvPr id="1" name="">
+          <a:extLst>
+            <a:ext uri="{FF2B5EF4-FFF2-40B4-BE49-F238E27FC236}">
+              <a16:creationId xmlns:a16="http://schemas.microsoft.com/office/drawing/2014/main" id="{6F56CB2A-4267-C224-E375-931CDCD967E9}"/>
+            </a:ext>
+          </a:extLst>
+        </p:cNvPr>
+        <p:cNvGrpSpPr/>
+        <p:nvPr/>
+      </p:nvGrpSpPr>
+      <p:grpSpPr>
+        <a:xfrm>
+          <a:off x="0" y="0"/>
+          <a:ext cx="0" cy="0"/>
+          <a:chOff x="0" y="0"/>
+          <a:chExt cx="0" cy="0"/>
+        </a:xfrm>
+      </p:grpSpPr>
+      <p:sp>
+        <p:nvSpPr>
+          <p:cNvPr id="2" name="Tytuł 1">
+            <a:extLst>
+              <a:ext uri="{FF2B5EF4-FFF2-40B4-BE49-F238E27FC236}">
+                <a16:creationId xmlns:a16="http://schemas.microsoft.com/office/drawing/2014/main" id="{C770498A-68E2-676C-2472-FD978B6B72B5}"/>
+              </a:ext>
+            </a:extLst>
+          </p:cNvPr>
+          <p:cNvSpPr>
+            <a:spLocks noGrp="1"/>
+          </p:cNvSpPr>
+          <p:nvPr>
+            <p:ph type="ctrTitle"/>
+          </p:nvPr>
+        </p:nvSpPr>
+        <p:spPr/>
+        <p:txBody>
+          <a:bodyPr>
+            <a:normAutofit/>
+          </a:bodyPr>
+          <a:lstStyle/>
+          <a:p>
+            <a:r>
+              <a:rPr lang="pl-PL" dirty="0"/>
+              <a:t>podsumowanie</a:t>
+            </a:r>
+          </a:p>
+        </p:txBody>
+      </p:sp>
+      <p:sp>
+        <p:nvSpPr>
+          <p:cNvPr id="3" name="Podtytuł 2">
+            <a:extLst>
+              <a:ext uri="{FF2B5EF4-FFF2-40B4-BE49-F238E27FC236}">
+                <a16:creationId xmlns:a16="http://schemas.microsoft.com/office/drawing/2014/main" id="{316E2806-0E20-6EE4-EA56-1B986D162A64}"/>
+              </a:ext>
+            </a:extLst>
+          </p:cNvPr>
+          <p:cNvSpPr>
+            <a:spLocks noGrp="1"/>
+          </p:cNvSpPr>
+          <p:nvPr>
+            <p:ph type="subTitle" idx="1"/>
+          </p:nvPr>
+        </p:nvSpPr>
+        <p:spPr/>
+        <p:txBody>
+          <a:bodyPr/>
+          <a:lstStyle/>
+          <a:p>
+            <a:endParaRPr lang="pl-PL" dirty="0"/>
+          </a:p>
+        </p:txBody>
+      </p:sp>
+    </p:spTree>
+    <p:extLst>
+      <p:ext uri="{BB962C8B-B14F-4D97-AF65-F5344CB8AC3E}">
+        <p14:creationId xmlns:p14="http://schemas.microsoft.com/office/powerpoint/2010/main" val="170481170"/>
+      </p:ext>
+    </p:extLst>
+  </p:cSld>
+  <p:clrMapOvr>
+    <a:masterClrMapping/>
+  </p:clrMapOvr>
+</p:sld>
+</file>
+
+<file path=ppt/slides/slide21.xml><?xml version="1.0" encoding="utf-8"?>
+<p:sld xmlns:a="http://schemas.openxmlformats.org/drawingml/2006/main" xmlns:r="http://schemas.openxmlformats.org/officeDocument/2006/relationships" xmlns:p="http://schemas.openxmlformats.org/presentationml/2006/main">
+  <p:cSld>
+    <p:spTree>
+      <p:nvGrpSpPr>
+        <p:cNvPr id="1" name="">
+          <a:extLst>
+            <a:ext uri="{FF2B5EF4-FFF2-40B4-BE49-F238E27FC236}">
+              <a16:creationId xmlns:a16="http://schemas.microsoft.com/office/drawing/2014/main" id="{1E4C2C64-0610-705D-4B33-C175F591F5D3}"/>
+            </a:ext>
+          </a:extLst>
+        </p:cNvPr>
+        <p:cNvGrpSpPr/>
+        <p:nvPr/>
+      </p:nvGrpSpPr>
+      <p:grpSpPr>
+        <a:xfrm>
+          <a:off x="0" y="0"/>
+          <a:ext cx="0" cy="0"/>
+          <a:chOff x="0" y="0"/>
+          <a:chExt cx="0" cy="0"/>
+        </a:xfrm>
+      </p:grpSpPr>
+      <p:sp>
+        <p:nvSpPr>
+          <p:cNvPr id="2" name="Tytuł 1">
+            <a:extLst>
+              <a:ext uri="{FF2B5EF4-FFF2-40B4-BE49-F238E27FC236}">
+                <a16:creationId xmlns:a16="http://schemas.microsoft.com/office/drawing/2014/main" id="{39614B22-EF1F-84F6-B3AC-DF1BA0E61F6D}"/>
+              </a:ext>
+            </a:extLst>
+          </p:cNvPr>
+          <p:cNvSpPr>
+            <a:spLocks noGrp="1"/>
+          </p:cNvSpPr>
+          <p:nvPr>
+            <p:ph type="title"/>
+          </p:nvPr>
+        </p:nvSpPr>
+        <p:spPr/>
+        <p:txBody>
+          <a:bodyPr/>
+          <a:lstStyle/>
+          <a:p>
+            <a:r>
+              <a:rPr lang="pl-PL" dirty="0"/>
+              <a:t>podsumowanie</a:t>
+            </a:r>
+          </a:p>
+        </p:txBody>
+      </p:sp>
+      <p:sp>
+        <p:nvSpPr>
+          <p:cNvPr id="3" name="Symbol zastępczy zawartości 2">
+            <a:extLst>
+              <a:ext uri="{FF2B5EF4-FFF2-40B4-BE49-F238E27FC236}">
+                <a16:creationId xmlns:a16="http://schemas.microsoft.com/office/drawing/2014/main" id="{58CDCCF8-17BC-EEAC-ACF0-DC61630F546E}"/>
+              </a:ext>
+            </a:extLst>
+          </p:cNvPr>
+          <p:cNvSpPr>
+            <a:spLocks noGrp="1"/>
+          </p:cNvSpPr>
+          <p:nvPr>
+            <p:ph idx="1"/>
+          </p:nvPr>
+        </p:nvSpPr>
+        <p:spPr/>
+        <p:txBody>
+          <a:bodyPr/>
+          <a:lstStyle/>
+          <a:p>
+            <a:endParaRPr lang="pl-PL" dirty="0"/>
+          </a:p>
+          <a:p>
+            <a:pPr lvl="1"/>
+            <a:r>
+              <a:rPr lang="pl-PL" dirty="0"/>
+              <a:t>Kwantyzacja modeli sieci neuronowych okazała się być bardzo pomocnym narzędziem do redukcji rozmiaru modelu, gdy:</a:t>
+            </a:r>
+          </a:p>
+          <a:p>
+            <a:pPr lvl="2"/>
+            <a:r>
+              <a:rPr lang="pl-PL" dirty="0"/>
+              <a:t>Ma on początkowo znaczną ilość parametrów</a:t>
+            </a:r>
+          </a:p>
+          <a:p>
+            <a:pPr lvl="2"/>
+            <a:r>
+              <a:rPr lang="pl-PL" dirty="0"/>
+              <a:t>Nie jest modelem regresyjnym, a klasyfikatorem</a:t>
+            </a:r>
+          </a:p>
+          <a:p>
+            <a:pPr lvl="1"/>
+            <a:r>
+              <a:rPr lang="pl-PL" dirty="0"/>
+              <a:t>W takich wypadkach kwantyzacja może powodować nawet 4-krotne zmniejszenie rozmiarów modelu bez wyraźnego spadku jakości uzyskiwanych wyników.</a:t>
+            </a:r>
+          </a:p>
+          <a:p>
+            <a:pPr lvl="1"/>
+            <a:r>
+              <a:rPr lang="pl-PL" dirty="0"/>
+              <a:t>Warto zauważyć, że ze względu na efekty </a:t>
+            </a:r>
+            <a:r>
+              <a:rPr lang="pl-PL" dirty="0" err="1"/>
+              <a:t>regularyzacji</a:t>
+            </a:r>
+            <a:r>
+              <a:rPr lang="pl-PL" dirty="0"/>
+              <a:t>, kwantyzacja do mniejszej ilości bitów może dawać lepsze wyniki.</a:t>
+            </a:r>
+          </a:p>
+        </p:txBody>
+      </p:sp>
+    </p:spTree>
+    <p:extLst>
+      <p:ext uri="{BB962C8B-B14F-4D97-AF65-F5344CB8AC3E}">
+        <p14:creationId xmlns:p14="http://schemas.microsoft.com/office/powerpoint/2010/main" val="895831235"/>
+      </p:ext>
+    </p:extLst>
+  </p:cSld>
+  <p:clrMapOvr>
+    <a:masterClrMapping/>
+  </p:clrMapOvr>
+</p:sld>
+</file>
+
+<file path=ppt/slides/slide22.xml><?xml version="1.0" encoding="utf-8"?>
+<p:sld xmlns:a="http://schemas.openxmlformats.org/drawingml/2006/main" xmlns:r="http://schemas.openxmlformats.org/officeDocument/2006/relationships" xmlns:p="http://schemas.openxmlformats.org/presentationml/2006/main">
+  <p:cSld>
+    <p:spTree>
+      <p:nvGrpSpPr>
+        <p:cNvPr id="1" name="">
+          <a:extLst>
+            <a:ext uri="{FF2B5EF4-FFF2-40B4-BE49-F238E27FC236}">
+              <a16:creationId xmlns:a16="http://schemas.microsoft.com/office/drawing/2014/main" id="{F6436A8D-607F-4D3F-14E7-92624325C70F}"/>
+            </a:ext>
+          </a:extLst>
+        </p:cNvPr>
+        <p:cNvGrpSpPr/>
+        <p:nvPr/>
+      </p:nvGrpSpPr>
+      <p:grpSpPr>
+        <a:xfrm>
+          <a:off x="0" y="0"/>
+          <a:ext cx="0" cy="0"/>
+          <a:chOff x="0" y="0"/>
+          <a:chExt cx="0" cy="0"/>
+        </a:xfrm>
+      </p:grpSpPr>
+      <p:sp>
+        <p:nvSpPr>
+          <p:cNvPr id="2" name="Tytuł 1">
+            <a:extLst>
+              <a:ext uri="{FF2B5EF4-FFF2-40B4-BE49-F238E27FC236}">
+                <a16:creationId xmlns:a16="http://schemas.microsoft.com/office/drawing/2014/main" id="{FC55E157-F339-8910-AF65-5BC29EE3745B}"/>
+              </a:ext>
+            </a:extLst>
+          </p:cNvPr>
+          <p:cNvSpPr>
+            <a:spLocks noGrp="1"/>
+          </p:cNvSpPr>
+          <p:nvPr>
+            <p:ph type="title"/>
+          </p:nvPr>
+        </p:nvSpPr>
+        <p:spPr/>
+        <p:txBody>
+          <a:bodyPr/>
+          <a:lstStyle/>
+          <a:p>
+            <a:r>
+              <a:rPr lang="pl-PL" dirty="0"/>
+              <a:t>podsumowanie</a:t>
+            </a:r>
+          </a:p>
+        </p:txBody>
+      </p:sp>
+      <p:sp>
+        <p:nvSpPr>
+          <p:cNvPr id="3" name="Symbol zastępczy zawartości 2">
+            <a:extLst>
+              <a:ext uri="{FF2B5EF4-FFF2-40B4-BE49-F238E27FC236}">
+                <a16:creationId xmlns:a16="http://schemas.microsoft.com/office/drawing/2014/main" id="{9534AE03-F18D-DF9D-2A69-B74E348CF8CB}"/>
+              </a:ext>
+            </a:extLst>
+          </p:cNvPr>
+          <p:cNvSpPr>
+            <a:spLocks noGrp="1"/>
+          </p:cNvSpPr>
+          <p:nvPr>
+            <p:ph idx="1"/>
+          </p:nvPr>
+        </p:nvSpPr>
+        <p:spPr/>
+        <p:txBody>
+          <a:bodyPr/>
+          <a:lstStyle/>
+          <a:p>
+            <a:endParaRPr lang="pl-PL" dirty="0"/>
+          </a:p>
+          <a:p>
+            <a:pPr lvl="1"/>
+            <a:r>
+              <a:rPr lang="pl-PL" dirty="0"/>
+              <a:t>Małe modele generalnie źle znoszą kwantyzację – jakość uzyskiwanych wyników znacznie spada, a oszczędzony rozmiar nie jest duży lub model wręcz zwiększa swój rozmiar.</a:t>
+            </a:r>
+          </a:p>
+          <a:p>
+            <a:pPr lvl="1"/>
+            <a:r>
+              <a:rPr lang="pl-PL" dirty="0"/>
+              <a:t>Również modele regresyjne uzyskują gorszą precyzję wyników.</a:t>
+            </a:r>
+          </a:p>
+        </p:txBody>
+      </p:sp>
+    </p:spTree>
+    <p:extLst>
+      <p:ext uri="{BB962C8B-B14F-4D97-AF65-F5344CB8AC3E}">
+        <p14:creationId xmlns:p14="http://schemas.microsoft.com/office/powerpoint/2010/main" val="3083739435"/>
+      </p:ext>
+    </p:extLst>
+  </p:cSld>
+  <p:clrMapOvr>
+    <a:masterClrMapping/>
+  </p:clrMapOvr>
+</p:sld>
+</file>
+
+<file path=ppt/slides/slide23.xml><?xml version="1.0" encoding="utf-8"?>
+<p:sld xmlns:a="http://schemas.openxmlformats.org/drawingml/2006/main" xmlns:r="http://schemas.openxmlformats.org/officeDocument/2006/relationships" xmlns:p="http://schemas.openxmlformats.org/presentationml/2006/main">
+  <p:cSld>
+    <p:spTree>
+      <p:nvGrpSpPr>
+        <p:cNvPr id="1" name="">
+          <a:extLst>
+            <a:ext uri="{FF2B5EF4-FFF2-40B4-BE49-F238E27FC236}">
+              <a16:creationId xmlns:a16="http://schemas.microsoft.com/office/drawing/2014/main" id="{CBA3ABC8-DE10-5368-734F-78953A32E570}"/>
+            </a:ext>
+          </a:extLst>
+        </p:cNvPr>
+        <p:cNvGrpSpPr/>
+        <p:nvPr/>
+      </p:nvGrpSpPr>
+      <p:grpSpPr>
+        <a:xfrm>
+          <a:off x="0" y="0"/>
+          <a:ext cx="0" cy="0"/>
+          <a:chOff x="0" y="0"/>
+          <a:chExt cx="0" cy="0"/>
+        </a:xfrm>
+      </p:grpSpPr>
+      <p:sp>
+        <p:nvSpPr>
+          <p:cNvPr id="2" name="Tytuł 1">
+            <a:extLst>
+              <a:ext uri="{FF2B5EF4-FFF2-40B4-BE49-F238E27FC236}">
+                <a16:creationId xmlns:a16="http://schemas.microsoft.com/office/drawing/2014/main" id="{292D47EE-D0F5-A2F1-9F45-7BB90AF5597D}"/>
+              </a:ext>
+            </a:extLst>
+          </p:cNvPr>
+          <p:cNvSpPr>
+            <a:spLocks noGrp="1"/>
+          </p:cNvSpPr>
+          <p:nvPr>
+            <p:ph type="ctrTitle"/>
+          </p:nvPr>
+        </p:nvSpPr>
+        <p:spPr/>
+        <p:txBody>
+          <a:bodyPr>
+            <a:normAutofit/>
+          </a:bodyPr>
+          <a:lstStyle/>
+          <a:p>
+            <a:r>
+              <a:rPr lang="pl-PL" dirty="0"/>
+              <a:t>Dziękujemy za uwagę</a:t>
+            </a:r>
+          </a:p>
+        </p:txBody>
+      </p:sp>
+      <p:sp>
+        <p:nvSpPr>
+          <p:cNvPr id="3" name="Podtytuł 2">
+            <a:extLst>
+              <a:ext uri="{FF2B5EF4-FFF2-40B4-BE49-F238E27FC236}">
+                <a16:creationId xmlns:a16="http://schemas.microsoft.com/office/drawing/2014/main" id="{BD4EFA8A-629E-E268-7A3F-BC7CCE894559}"/>
+              </a:ext>
+            </a:extLst>
+          </p:cNvPr>
+          <p:cNvSpPr>
+            <a:spLocks noGrp="1"/>
+          </p:cNvSpPr>
+          <p:nvPr>
+            <p:ph type="subTitle" idx="1"/>
+          </p:nvPr>
+        </p:nvSpPr>
+        <p:spPr/>
+        <p:txBody>
+          <a:bodyPr/>
+          <a:lstStyle/>
+          <a:p>
+            <a:endParaRPr lang="pl-PL" dirty="0"/>
+          </a:p>
+        </p:txBody>
+      </p:sp>
+    </p:spTree>
+    <p:extLst>
+      <p:ext uri="{BB962C8B-B14F-4D97-AF65-F5344CB8AC3E}">
+        <p14:creationId xmlns:p14="http://schemas.microsoft.com/office/powerpoint/2010/main" val="2422881592"/>
       </p:ext>
     </p:extLst>
   </p:cSld>
@@ -6296,13 +8260,8 @@
             </a:r>
             <a:r>
               <a:rPr lang="pl-PL" dirty="0"/>
-              <a:t> sieci? (w MB zajmowanych na </a:t>
-            </a:r>
-            <a:r>
-              <a:rPr lang="pl-PL"/>
-              <a:t>dysku)</a:t>
-            </a:r>
-            <a:endParaRPr lang="pl-PL" dirty="0"/>
+              <a:t> sieci? (w MB zajmowanych na dysku)</a:t>
+            </a:r>
           </a:p>
         </p:txBody>
       </p:sp>
@@ -6465,6 +8424,347 @@
     <p:extLst>
       <p:ext uri="{BB962C8B-B14F-4D97-AF65-F5344CB8AC3E}">
         <p14:creationId xmlns:p14="http://schemas.microsoft.com/office/powerpoint/2010/main" val="2221480356"/>
+      </p:ext>
+    </p:extLst>
+  </p:cSld>
+  <p:clrMapOvr>
+    <a:masterClrMapping/>
+  </p:clrMapOvr>
+</p:sld>
+</file>
+
+<file path=ppt/slides/slide7.xml><?xml version="1.0" encoding="utf-8"?>
+<p:sld xmlns:a="http://schemas.openxmlformats.org/drawingml/2006/main" xmlns:r="http://schemas.openxmlformats.org/officeDocument/2006/relationships" xmlns:p="http://schemas.openxmlformats.org/presentationml/2006/main">
+  <p:cSld>
+    <p:spTree>
+      <p:nvGrpSpPr>
+        <p:cNvPr id="1" name="">
+          <a:extLst>
+            <a:ext uri="{FF2B5EF4-FFF2-40B4-BE49-F238E27FC236}">
+              <a16:creationId xmlns:a16="http://schemas.microsoft.com/office/drawing/2014/main" id="{0B332AB6-C5B1-612C-F8A9-707B8E0F38C5}"/>
+            </a:ext>
+          </a:extLst>
+        </p:cNvPr>
+        <p:cNvGrpSpPr/>
+        <p:nvPr/>
+      </p:nvGrpSpPr>
+      <p:grpSpPr>
+        <a:xfrm>
+          <a:off x="0" y="0"/>
+          <a:ext cx="0" cy="0"/>
+          <a:chOff x="0" y="0"/>
+          <a:chExt cx="0" cy="0"/>
+        </a:xfrm>
+      </p:grpSpPr>
+      <p:sp>
+        <p:nvSpPr>
+          <p:cNvPr id="2" name="Tytuł 1">
+            <a:extLst>
+              <a:ext uri="{FF2B5EF4-FFF2-40B4-BE49-F238E27FC236}">
+                <a16:creationId xmlns:a16="http://schemas.microsoft.com/office/drawing/2014/main" id="{927F28BB-1647-0F2A-DA94-78BA4E465F3A}"/>
+              </a:ext>
+            </a:extLst>
+          </p:cNvPr>
+          <p:cNvSpPr>
+            <a:spLocks noGrp="1"/>
+          </p:cNvSpPr>
+          <p:nvPr>
+            <p:ph type="ctrTitle"/>
+          </p:nvPr>
+        </p:nvSpPr>
+        <p:spPr/>
+        <p:txBody>
+          <a:bodyPr>
+            <a:normAutofit/>
+          </a:bodyPr>
+          <a:lstStyle/>
+          <a:p>
+            <a:r>
+              <a:rPr lang="pl-PL" dirty="0"/>
+              <a:t>Rozmiary sieci</a:t>
+            </a:r>
+          </a:p>
+        </p:txBody>
+      </p:sp>
+      <p:sp>
+        <p:nvSpPr>
+          <p:cNvPr id="3" name="Podtytuł 2">
+            <a:extLst>
+              <a:ext uri="{FF2B5EF4-FFF2-40B4-BE49-F238E27FC236}">
+                <a16:creationId xmlns:a16="http://schemas.microsoft.com/office/drawing/2014/main" id="{2105CE59-F490-0FE9-DDA0-F670F32D3296}"/>
+              </a:ext>
+            </a:extLst>
+          </p:cNvPr>
+          <p:cNvSpPr>
+            <a:spLocks noGrp="1"/>
+          </p:cNvSpPr>
+          <p:nvPr>
+            <p:ph type="subTitle" idx="1"/>
+          </p:nvPr>
+        </p:nvSpPr>
+        <p:spPr/>
+        <p:txBody>
+          <a:bodyPr/>
+          <a:lstStyle/>
+          <a:p>
+            <a:endParaRPr lang="pl-PL" dirty="0"/>
+          </a:p>
+        </p:txBody>
+      </p:sp>
+    </p:spTree>
+    <p:extLst>
+      <p:ext uri="{BB962C8B-B14F-4D97-AF65-F5344CB8AC3E}">
+        <p14:creationId xmlns:p14="http://schemas.microsoft.com/office/powerpoint/2010/main" val="1493772514"/>
+      </p:ext>
+    </p:extLst>
+  </p:cSld>
+  <p:clrMapOvr>
+    <a:masterClrMapping/>
+  </p:clrMapOvr>
+</p:sld>
+</file>
+
+<file path=ppt/slides/slide8.xml><?xml version="1.0" encoding="utf-8"?>
+<p:sld xmlns:a="http://schemas.openxmlformats.org/drawingml/2006/main" xmlns:r="http://schemas.openxmlformats.org/officeDocument/2006/relationships" xmlns:p="http://schemas.openxmlformats.org/presentationml/2006/main">
+  <p:cSld>
+    <p:spTree>
+      <p:nvGrpSpPr>
+        <p:cNvPr id="1" name="">
+          <a:extLst>
+            <a:ext uri="{FF2B5EF4-FFF2-40B4-BE49-F238E27FC236}">
+              <a16:creationId xmlns:a16="http://schemas.microsoft.com/office/drawing/2014/main" id="{F0D956F0-4DD1-46D6-4717-47C3E6315622}"/>
+            </a:ext>
+          </a:extLst>
+        </p:cNvPr>
+        <p:cNvGrpSpPr/>
+        <p:nvPr/>
+      </p:nvGrpSpPr>
+      <p:grpSpPr>
+        <a:xfrm>
+          <a:off x="0" y="0"/>
+          <a:ext cx="0" cy="0"/>
+          <a:chOff x="0" y="0"/>
+          <a:chExt cx="0" cy="0"/>
+        </a:xfrm>
+      </p:grpSpPr>
+      <p:sp>
+        <p:nvSpPr>
+          <p:cNvPr id="2" name="Tytuł 1">
+            <a:extLst>
+              <a:ext uri="{FF2B5EF4-FFF2-40B4-BE49-F238E27FC236}">
+                <a16:creationId xmlns:a16="http://schemas.microsoft.com/office/drawing/2014/main" id="{7F3E20F0-E735-AA80-3788-0824FEB88722}"/>
+              </a:ext>
+            </a:extLst>
+          </p:cNvPr>
+          <p:cNvSpPr>
+            <a:spLocks noGrp="1"/>
+          </p:cNvSpPr>
+          <p:nvPr>
+            <p:ph type="title"/>
+          </p:nvPr>
+        </p:nvSpPr>
+        <p:spPr/>
+        <p:txBody>
+          <a:bodyPr/>
+          <a:lstStyle/>
+          <a:p>
+            <a:r>
+              <a:rPr lang="pl-PL" dirty="0"/>
+              <a:t>Mały MLP</a:t>
+            </a:r>
+          </a:p>
+        </p:txBody>
+      </p:sp>
+      <p:sp>
+        <p:nvSpPr>
+          <p:cNvPr id="3" name="Symbol zastępczy zawartości 2">
+            <a:extLst>
+              <a:ext uri="{FF2B5EF4-FFF2-40B4-BE49-F238E27FC236}">
+                <a16:creationId xmlns:a16="http://schemas.microsoft.com/office/drawing/2014/main" id="{E8FC2013-DAD5-6DA5-8A9A-A7330A6D0855}"/>
+              </a:ext>
+            </a:extLst>
+          </p:cNvPr>
+          <p:cNvSpPr>
+            <a:spLocks noGrp="1"/>
+          </p:cNvSpPr>
+          <p:nvPr>
+            <p:ph idx="1"/>
+          </p:nvPr>
+        </p:nvSpPr>
+        <p:spPr/>
+        <p:txBody>
+          <a:bodyPr/>
+          <a:lstStyle/>
+          <a:p>
+            <a:endParaRPr lang="pl-PL" dirty="0"/>
+          </a:p>
+          <a:p>
+            <a:pPr marL="457200" lvl="1" indent="0">
+              <a:buNone/>
+            </a:pPr>
+            <a:endParaRPr lang="pl-PL" dirty="0"/>
+          </a:p>
+        </p:txBody>
+      </p:sp>
+      <p:pic>
+        <p:nvPicPr>
+          <p:cNvPr id="5" name="Obraz 4">
+            <a:extLst>
+              <a:ext uri="{FF2B5EF4-FFF2-40B4-BE49-F238E27FC236}">
+                <a16:creationId xmlns:a16="http://schemas.microsoft.com/office/drawing/2014/main" id="{BD93EEBB-D87D-BD17-1CD7-2A764D7307CE}"/>
+              </a:ext>
+            </a:extLst>
+          </p:cNvPr>
+          <p:cNvPicPr>
+            <a:picLocks noChangeAspect="1"/>
+          </p:cNvPicPr>
+          <p:nvPr/>
+        </p:nvPicPr>
+        <p:blipFill>
+          <a:blip r:embed="rId2"/>
+          <a:stretch>
+            <a:fillRect/>
+          </a:stretch>
+        </p:blipFill>
+        <p:spPr>
+          <a:xfrm>
+            <a:off x="2196668" y="2130212"/>
+            <a:ext cx="8024916" cy="3843867"/>
+          </a:xfrm>
+          <a:prstGeom prst="rect">
+            <a:avLst/>
+          </a:prstGeom>
+        </p:spPr>
+      </p:pic>
+    </p:spTree>
+    <p:extLst>
+      <p:ext uri="{BB962C8B-B14F-4D97-AF65-F5344CB8AC3E}">
+        <p14:creationId xmlns:p14="http://schemas.microsoft.com/office/powerpoint/2010/main" val="2652723699"/>
+      </p:ext>
+    </p:extLst>
+  </p:cSld>
+  <p:clrMapOvr>
+    <a:masterClrMapping/>
+  </p:clrMapOvr>
+</p:sld>
+</file>
+
+<file path=ppt/slides/slide9.xml><?xml version="1.0" encoding="utf-8"?>
+<p:sld xmlns:a="http://schemas.openxmlformats.org/drawingml/2006/main" xmlns:r="http://schemas.openxmlformats.org/officeDocument/2006/relationships" xmlns:p="http://schemas.openxmlformats.org/presentationml/2006/main">
+  <p:cSld>
+    <p:spTree>
+      <p:nvGrpSpPr>
+        <p:cNvPr id="1" name="">
+          <a:extLst>
+            <a:ext uri="{FF2B5EF4-FFF2-40B4-BE49-F238E27FC236}">
+              <a16:creationId xmlns:a16="http://schemas.microsoft.com/office/drawing/2014/main" id="{19E04871-F6F2-093E-75D0-9C18B130E7E7}"/>
+            </a:ext>
+          </a:extLst>
+        </p:cNvPr>
+        <p:cNvGrpSpPr/>
+        <p:nvPr/>
+      </p:nvGrpSpPr>
+      <p:grpSpPr>
+        <a:xfrm>
+          <a:off x="0" y="0"/>
+          <a:ext cx="0" cy="0"/>
+          <a:chOff x="0" y="0"/>
+          <a:chExt cx="0" cy="0"/>
+        </a:xfrm>
+      </p:grpSpPr>
+      <p:sp>
+        <p:nvSpPr>
+          <p:cNvPr id="2" name="Tytuł 1">
+            <a:extLst>
+              <a:ext uri="{FF2B5EF4-FFF2-40B4-BE49-F238E27FC236}">
+                <a16:creationId xmlns:a16="http://schemas.microsoft.com/office/drawing/2014/main" id="{61525B9F-C6E8-65FE-9B61-02C8494315DC}"/>
+              </a:ext>
+            </a:extLst>
+          </p:cNvPr>
+          <p:cNvSpPr>
+            <a:spLocks noGrp="1"/>
+          </p:cNvSpPr>
+          <p:nvPr>
+            <p:ph type="title"/>
+          </p:nvPr>
+        </p:nvSpPr>
+        <p:spPr/>
+        <p:txBody>
+          <a:bodyPr/>
+          <a:lstStyle/>
+          <a:p>
+            <a:r>
+              <a:rPr lang="pl-PL" dirty="0"/>
+              <a:t>Duży MLP</a:t>
+            </a:r>
+          </a:p>
+        </p:txBody>
+      </p:sp>
+      <p:sp>
+        <p:nvSpPr>
+          <p:cNvPr id="3" name="Symbol zastępczy zawartości 2">
+            <a:extLst>
+              <a:ext uri="{FF2B5EF4-FFF2-40B4-BE49-F238E27FC236}">
+                <a16:creationId xmlns:a16="http://schemas.microsoft.com/office/drawing/2014/main" id="{473DB5B4-ACE9-FC27-FB47-19C4726E0325}"/>
+              </a:ext>
+            </a:extLst>
+          </p:cNvPr>
+          <p:cNvSpPr>
+            <a:spLocks noGrp="1"/>
+          </p:cNvSpPr>
+          <p:nvPr>
+            <p:ph idx="1"/>
+          </p:nvPr>
+        </p:nvSpPr>
+        <p:spPr/>
+        <p:txBody>
+          <a:bodyPr/>
+          <a:lstStyle/>
+          <a:p>
+            <a:endParaRPr lang="pl-PL" dirty="0"/>
+          </a:p>
+          <a:p>
+            <a:pPr marL="457200" lvl="1" indent="0">
+              <a:buNone/>
+            </a:pPr>
+            <a:endParaRPr lang="pl-PL" dirty="0"/>
+          </a:p>
+        </p:txBody>
+      </p:sp>
+      <p:pic>
+        <p:nvPicPr>
+          <p:cNvPr id="5" name="Obraz 4">
+            <a:extLst>
+              <a:ext uri="{FF2B5EF4-FFF2-40B4-BE49-F238E27FC236}">
+                <a16:creationId xmlns:a16="http://schemas.microsoft.com/office/drawing/2014/main" id="{10B90977-A2CF-8B66-BA59-F05C340E8EE3}"/>
+              </a:ext>
+            </a:extLst>
+          </p:cNvPr>
+          <p:cNvPicPr>
+            <a:picLocks noChangeAspect="1"/>
+          </p:cNvPicPr>
+          <p:nvPr/>
+        </p:nvPicPr>
+        <p:blipFill>
+          <a:blip r:embed="rId2"/>
+          <a:stretch>
+            <a:fillRect/>
+          </a:stretch>
+        </p:blipFill>
+        <p:spPr>
+          <a:xfrm>
+            <a:off x="2165350" y="2057401"/>
+            <a:ext cx="7861300" cy="3919270"/>
+          </a:xfrm>
+          <a:prstGeom prst="rect">
+            <a:avLst/>
+          </a:prstGeom>
+        </p:spPr>
+      </p:pic>
+    </p:spTree>
+    <p:extLst>
+      <p:ext uri="{BB962C8B-B14F-4D97-AF65-F5344CB8AC3E}">
+        <p14:creationId xmlns:p14="http://schemas.microsoft.com/office/powerpoint/2010/main" val="2771568647"/>
       </p:ext>
     </p:extLst>
   </p:cSld>

</xml_diff>